<commit_message>
docs: alcance sin funcionalidades no solicitadas en README y presentación
Co-Authored-By: Claude Opus 5.5 <noreply@anthropic.com>
</commit_message>
<xml_diff>
--- a/docs/presentacion/presentacion-conciliador.pptx
+++ b/docs/presentacion/presentacion-conciliador.pptx
@@ -111,27 +111,27 @@
   <p:extLst>
     <p:ext uri="{521415D9-36F7-43E2-AB2F-B90AF26B5E84}">
       <p14:sectionLst xmlns:p14="http://schemas.microsoft.com/office/powerpoint/2010/main">
-        <p14:section name="Problema" id="{b2cd2ebe-fa3b-e4d7-dd57-3b16b82dc86e}">
+        <p14:section name="Problema" id="{cfc54839-e2ff-bd4b-4dbc-4b3d4b0f5cac}">
           <p14:sldIdLst>
             <p14:sldId id="256"/>
           </p14:sldIdLst>
         </p14:section>
-        <p14:section name="Solución" id="{d361e2a1-f2d4-808c-c296-6c8bf0b6006f}">
+        <p14:section name="Solución" id="{be9f0658-4da1-934b-1116-28f95475f5b0}">
           <p14:sldIdLst>
             <p14:sldId id="257"/>
           </p14:sldIdLst>
         </p14:section>
-        <p14:section name="Flujo" id="{264576e3-aba9-244a-bcb8-b62a7c384309}">
+        <p14:section name="Flujo" id="{01cbd5ce-5001-01db-a2ab-476c34b76a0f}">
           <p14:sldIdLst>
             <p14:sldId id="258"/>
           </p14:sldIdLst>
         </p14:section>
-        <p14:section name="Resultados" id="{ad9125fe-ae29-f8c6-460d-24755d11de7c}">
+        <p14:section name="Resultados" id="{9e275633-0964-276b-d29a-7f84fae28323}">
           <p14:sldIdLst>
             <p14:sldId id="259"/>
           </p14:sldIdLst>
         </p14:section>
-        <p14:section name="Beneficios" id="{0dd82d4c-28cd-416a-e26b-a341f153c364}">
+        <p14:section name="Beneficios" id="{e4697d09-1904-3d74-5141-54f477b633c8}">
           <p14:sldIdLst>
             <p14:sldId id="260"/>
           </p14:sldIdLst>
@@ -1176,7 +1176,7 @@
           <a:p>
             <a:r>
               <a:rPr lang="en-US" dirty="0"/>
-              <a:t>Los beneficios son cualitativos: no medimos tiempos reales del proceso actual, así que no prometemos un porcentaje de ahorro. Lo que sí cambia es que cada diferencia queda explicada y con criterios iguales para todos. Como siguientes pasos proponemos validar las reglas con el equipo, en especial las interpretaciones documentadas, y luego evolucionar a histórico, exportación e integración.</a:t>
+              <a:t>El enunciado describe tres problemas del proceso actual: consume tiempo, dificulta la trazabilidad y puede generar reprocesos. Esta diapositiva muestra qué cambia en cada uno con el prototipo. Los beneficios son cualitativos: no medimos tiempos reales del proceso actual, así que no se promete un porcentaje de ahorro.</a:t>
             </a:r>
             <a:endParaRPr lang="en-US" dirty="0"/>
           </a:p>
@@ -4797,7 +4797,7 @@
                   <a:schemeClr val="tx1"/>
                 </a:solidFill>
               </a:rPr>
-              <a:t>Beneficios esperados y siguientes pasos</a:t>
+              <a:t>Beneficios esperados</a:t>
             </a:r>
             <a:endParaRPr lang="en-US" sz="3400" dirty="0"/>
           </a:p>
@@ -4805,14 +4805,86 @@
       </p:sp>
       <p:sp>
         <p:nvSpPr>
-          <p:cNvPr id="3" name="Círculo Menos trabajo manual"/>
+          <p:cNvPr id="3" name="Encabezado hoy"/>
+          <p:cNvSpPr txBox="1"/>
+          <p:nvPr/>
+        </p:nvSpPr>
+        <p:spPr>
+          <a:xfrm>
+            <a:off x="4160520" y="1371600"/>
+            <a:ext cx="3703320" cy="365760"/>
+          </a:xfrm>
+          <a:prstGeom prst="rect">
+            <a:avLst/>
+          </a:prstGeom>
+          <a:noFill/>
+          <a:ln/>
+        </p:spPr>
+        <p:txBody>
+          <a:bodyPr wrap="square" lIns="0" tIns="0" rIns="0" bIns="0" rtlCol="0" anchor="ctr"/>
+          <a:lstStyle/>
+          <a:p>
+            <a:pPr indent="0" marL="0">
+              <a:buNone/>
+            </a:pPr>
+            <a:r>
+              <a:rPr lang="en-US" sz="1500" b="1" dirty="0">
+                <a:solidFill>
+                  <a:schemeClr val="tx2"/>
+                </a:solidFill>
+              </a:rPr>
+              <a:t>Hoy (proceso manual)</a:t>
+            </a:r>
+            <a:endParaRPr lang="en-US" sz="1500" dirty="0"/>
+          </a:p>
+        </p:txBody>
+      </p:sp>
+      <p:sp>
+        <p:nvSpPr>
+          <p:cNvPr id="4" name="Encabezado prototipo"/>
+          <p:cNvSpPr txBox="1"/>
+          <p:nvPr/>
+        </p:nvSpPr>
+        <p:spPr>
+          <a:xfrm>
+            <a:off x="7955280" y="1371600"/>
+            <a:ext cx="3703320" cy="365760"/>
+          </a:xfrm>
+          <a:prstGeom prst="rect">
+            <a:avLst/>
+          </a:prstGeom>
+          <a:noFill/>
+          <a:ln/>
+        </p:spPr>
+        <p:txBody>
+          <a:bodyPr wrap="square" lIns="0" tIns="0" rIns="0" bIns="0" rtlCol="0" anchor="ctr"/>
+          <a:lstStyle/>
+          <a:p>
+            <a:pPr indent="0" marL="0">
+              <a:buNone/>
+            </a:pPr>
+            <a:r>
+              <a:rPr lang="en-US" sz="1500" b="1" dirty="0">
+                <a:solidFill>
+                  <a:schemeClr val="tx1"/>
+                </a:solidFill>
+              </a:rPr>
+              <a:t>Con el prototipo</a:t>
+            </a:r>
+            <a:endParaRPr lang="en-US" sz="1500" dirty="0"/>
+          </a:p>
+        </p:txBody>
+      </p:sp>
+      <p:sp>
+        <p:nvSpPr>
+          <p:cNvPr id="5" name="Círculo Menos trabajo manual"/>
           <p:cNvSpPr/>
           <p:nvPr/>
         </p:nvSpPr>
         <p:spPr>
           <a:xfrm>
-            <a:off x="548640" y="1508760"/>
-            <a:ext cx="685800" cy="685800"/>
+            <a:off x="548640" y="2011680"/>
+            <a:ext cx="640080" cy="640080"/>
           </a:xfrm>
           <a:prstGeom prst="ellipse">
             <a:avLst/>
@@ -4830,7 +4902,7 @@
       </p:sp>
       <p:pic>
         <p:nvPicPr>
-          <p:cNvPr id="4" name="Ícono Menos trabajo manual" descr="Menos trabajo manual">    </p:cNvPr>
+          <p:cNvPr id="6" name="Ícono Menos trabajo manual" descr="Menos trabajo manual">    </p:cNvPr>
           <p:cNvPicPr>
             <a:picLocks noChangeAspect="1"/>
           </p:cNvPicPr>
@@ -4844,8 +4916,8 @@
         </p:blipFill>
         <p:spPr>
           <a:xfrm>
-            <a:off x="722376" y="1682496"/>
-            <a:ext cx="338328" cy="338328"/>
+            <a:off x="708660" y="2171700"/>
+            <a:ext cx="320040" cy="320040"/>
           </a:xfrm>
           <a:prstGeom prst="rect">
             <a:avLst/>
@@ -4854,14 +4926,14 @@
       </p:pic>
       <p:sp>
         <p:nvSpPr>
-          <p:cNvPr id="5" name="Beneficio Menos trabajo manual"/>
+          <p:cNvPr id="7" name="Beneficio Menos trabajo manual"/>
           <p:cNvSpPr txBox="1"/>
           <p:nvPr/>
         </p:nvSpPr>
         <p:spPr>
           <a:xfrm>
-            <a:off x="1463040" y="1463040"/>
-            <a:ext cx="4572000" cy="960120"/>
+            <a:off x="1371600" y="1874520"/>
+            <a:ext cx="2606040" cy="914400"/>
           </a:xfrm>
           <a:prstGeom prst="rect">
             <a:avLst/>
@@ -4870,7 +4942,7 @@
           <a:ln/>
         </p:spPr>
         <p:txBody>
-          <a:bodyPr wrap="square" lIns="0" tIns="0" rIns="0" bIns="0" rtlCol="0" anchor="t"/>
+          <a:bodyPr wrap="square" lIns="0" tIns="0" rIns="0" bIns="0" rtlCol="0" anchor="ctr"/>
           <a:lstStyle/>
           <a:p>
             <a:pPr indent="0" marL="0">
@@ -4886,6 +4958,55 @@
             </a:r>
             <a:endParaRPr lang="en-US" sz="1700" dirty="0"/>
           </a:p>
+        </p:txBody>
+      </p:sp>
+      <p:sp>
+        <p:nvSpPr>
+          <p:cNvPr id="8" name="Hoy Menos trabajo manual"/>
+          <p:cNvSpPr/>
+          <p:nvPr/>
+        </p:nvSpPr>
+        <p:spPr>
+          <a:xfrm>
+            <a:off x="4160520" y="1874520"/>
+            <a:ext cx="3703320" cy="914400"/>
+          </a:xfrm>
+          <a:prstGeom prst="roundRect">
+            <a:avLst>
+              <a:gd name="adj" fmla="val 10000"/>
+            </a:avLst>
+          </a:prstGeom>
+          <a:solidFill>
+            <a:schemeClr val="bg2"/>
+          </a:solidFill>
+          <a:ln w="12700">
+            <a:solidFill>
+              <a:schemeClr val="bg2"/>
+            </a:solidFill>
+            <a:prstDash val="solid"/>
+          </a:ln>
+        </p:spPr>
+      </p:sp>
+      <p:sp>
+        <p:nvSpPr>
+          <p:cNvPr id="9" name="Texto hoy Menos trabajo manual"/>
+          <p:cNvSpPr txBox="1"/>
+          <p:nvPr/>
+        </p:nvSpPr>
+        <p:spPr>
+          <a:xfrm>
+            <a:off x="4343400" y="1874520"/>
+            <a:ext cx="3337560" cy="914400"/>
+          </a:xfrm>
+          <a:prstGeom prst="rect">
+            <a:avLst/>
+          </a:prstGeom>
+          <a:noFill/>
+          <a:ln/>
+        </p:spPr>
+        <p:txBody>
+          <a:bodyPr wrap="square" lIns="0" tIns="0" rIns="0" bIns="0" rtlCol="0" anchor="ctr"/>
+          <a:lstStyle/>
           <a:p>
             <a:pPr indent="0" marL="0">
               <a:buNone/>
@@ -4896,25 +5017,27 @@
                   <a:schemeClr val="tx2"/>
                 </a:solidFill>
               </a:rPr>
-              <a:t>El cruce de los dos archivos se hace en segundos.</a:t>
-            </a:r>
-            <a:endParaRPr lang="en-US" sz="1700" dirty="0"/>
-          </a:p>
-        </p:txBody>
-      </p:sp>
-      <p:sp>
-        <p:nvSpPr>
-          <p:cNvPr id="6" name="Círculo Cada diferencia explicada"/>
+              <a:t>Un analista cruza los dos archivos factura por factura.</a:t>
+            </a:r>
+            <a:endParaRPr lang="en-US" sz="1400" dirty="0"/>
+          </a:p>
+        </p:txBody>
+      </p:sp>
+      <p:sp>
+        <p:nvSpPr>
+          <p:cNvPr id="10" name="Prototipo Menos trabajo manual"/>
           <p:cNvSpPr/>
           <p:nvPr/>
         </p:nvSpPr>
         <p:spPr>
           <a:xfrm>
-            <a:off x="548640" y="2670048"/>
-            <a:ext cx="685800" cy="685800"/>
-          </a:xfrm>
-          <a:prstGeom prst="ellipse">
-            <a:avLst/>
+            <a:off x="7955280" y="1874520"/>
+            <a:ext cx="3703320" cy="914400"/>
+          </a:xfrm>
+          <a:prstGeom prst="roundRect">
+            <a:avLst>
+              <a:gd name="adj" fmla="val 10000"/>
+            </a:avLst>
           </a:prstGeom>
           <a:solidFill>
             <a:schemeClr val="accent1"/>
@@ -4927,9 +5050,70 @@
           </a:ln>
         </p:spPr>
       </p:sp>
+      <p:sp>
+        <p:nvSpPr>
+          <p:cNvPr id="11" name="Texto prototipo Menos trabajo manual"/>
+          <p:cNvSpPr txBox="1"/>
+          <p:nvPr/>
+        </p:nvSpPr>
+        <p:spPr>
+          <a:xfrm>
+            <a:off x="8138160" y="1874520"/>
+            <a:ext cx="3337560" cy="914400"/>
+          </a:xfrm>
+          <a:prstGeom prst="rect">
+            <a:avLst/>
+          </a:prstGeom>
+          <a:noFill/>
+          <a:ln/>
+        </p:spPr>
+        <p:txBody>
+          <a:bodyPr wrap="square" lIns="0" tIns="0" rIns="0" bIns="0" rtlCol="0" anchor="ctr"/>
+          <a:lstStyle/>
+          <a:p>
+            <a:pPr indent="0" marL="0">
+              <a:buNone/>
+            </a:pPr>
+            <a:r>
+              <a:rPr lang="en-US" sz="1400" dirty="0">
+                <a:solidFill>
+                  <a:schemeClr val="tx1"/>
+                </a:solidFill>
+              </a:rPr>
+              <a:t>El cruce se hace automáticamente al cargar los archivos.</a:t>
+            </a:r>
+            <a:endParaRPr lang="en-US" sz="1400" dirty="0"/>
+          </a:p>
+        </p:txBody>
+      </p:sp>
+      <p:sp>
+        <p:nvSpPr>
+          <p:cNvPr id="12" name="Círculo Trazabilidad"/>
+          <p:cNvSpPr/>
+          <p:nvPr/>
+        </p:nvSpPr>
+        <p:spPr>
+          <a:xfrm>
+            <a:off x="548640" y="3081528"/>
+            <a:ext cx="640080" cy="640080"/>
+          </a:xfrm>
+          <a:prstGeom prst="ellipse">
+            <a:avLst/>
+          </a:prstGeom>
+          <a:solidFill>
+            <a:schemeClr val="accent1"/>
+          </a:solidFill>
+          <a:ln w="12700">
+            <a:solidFill>
+              <a:schemeClr val="accent1"/>
+            </a:solidFill>
+            <a:prstDash val="solid"/>
+          </a:ln>
+        </p:spPr>
+      </p:sp>
       <p:pic>
         <p:nvPicPr>
-          <p:cNvPr id="7" name="Ícono Cada diferencia explicada" descr="Cada diferencia explicada">    </p:cNvPr>
+          <p:cNvPr id="13" name="Ícono Trazabilidad" descr="Trazabilidad">    </p:cNvPr>
           <p:cNvPicPr>
             <a:picLocks noChangeAspect="1"/>
           </p:cNvPicPr>
@@ -4943,8 +5127,8 @@
         </p:blipFill>
         <p:spPr>
           <a:xfrm>
-            <a:off x="722376" y="2843784"/>
-            <a:ext cx="338328" cy="338328"/>
+            <a:off x="708660" y="3241548"/>
+            <a:ext cx="320040" cy="320040"/>
           </a:xfrm>
           <a:prstGeom prst="rect">
             <a:avLst/>
@@ -4953,14 +5137,14 @@
       </p:pic>
       <p:sp>
         <p:nvSpPr>
-          <p:cNvPr id="8" name="Beneficio Cada diferencia explicada"/>
+          <p:cNvPr id="14" name="Beneficio Trazabilidad"/>
           <p:cNvSpPr txBox="1"/>
           <p:nvPr/>
         </p:nvSpPr>
         <p:spPr>
           <a:xfrm>
-            <a:off x="1463040" y="2624328"/>
-            <a:ext cx="4572000" cy="960120"/>
+            <a:off x="1371600" y="2944368"/>
+            <a:ext cx="2606040" cy="914400"/>
           </a:xfrm>
           <a:prstGeom prst="rect">
             <a:avLst/>
@@ -4969,7 +5153,7 @@
           <a:ln/>
         </p:spPr>
         <p:txBody>
-          <a:bodyPr wrap="square" lIns="0" tIns="0" rIns="0" bIns="0" rtlCol="0" anchor="t"/>
+          <a:bodyPr wrap="square" lIns="0" tIns="0" rIns="0" bIns="0" rtlCol="0" anchor="ctr"/>
           <a:lstStyle/>
           <a:p>
             <a:pPr indent="0" marL="0">
@@ -4981,10 +5165,59 @@
                   <a:schemeClr val="tx1"/>
                 </a:solidFill>
               </a:rPr>
-              <a:t>Cada diferencia explicada</a:t>
+              <a:t>Trazabilidad</a:t>
             </a:r>
             <a:endParaRPr lang="en-US" sz="1700" dirty="0"/>
           </a:p>
+        </p:txBody>
+      </p:sp>
+      <p:sp>
+        <p:nvSpPr>
+          <p:cNvPr id="15" name="Hoy Trazabilidad"/>
+          <p:cNvSpPr/>
+          <p:nvPr/>
+        </p:nvSpPr>
+        <p:spPr>
+          <a:xfrm>
+            <a:off x="4160520" y="2944368"/>
+            <a:ext cx="3703320" cy="914400"/>
+          </a:xfrm>
+          <a:prstGeom prst="roundRect">
+            <a:avLst>
+              <a:gd name="adj" fmla="val 10000"/>
+            </a:avLst>
+          </a:prstGeom>
+          <a:solidFill>
+            <a:schemeClr val="bg2"/>
+          </a:solidFill>
+          <a:ln w="12700">
+            <a:solidFill>
+              <a:schemeClr val="bg2"/>
+            </a:solidFill>
+            <a:prstDash val="solid"/>
+          </a:ln>
+        </p:spPr>
+      </p:sp>
+      <p:sp>
+        <p:nvSpPr>
+          <p:cNvPr id="16" name="Texto hoy Trazabilidad"/>
+          <p:cNvSpPr txBox="1"/>
+          <p:nvPr/>
+        </p:nvSpPr>
+        <p:spPr>
+          <a:xfrm>
+            <a:off x="4343400" y="2944368"/>
+            <a:ext cx="3337560" cy="914400"/>
+          </a:xfrm>
+          <a:prstGeom prst="rect">
+            <a:avLst/>
+          </a:prstGeom>
+          <a:noFill/>
+          <a:ln/>
+        </p:spPr>
+        <p:txBody>
+          <a:bodyPr wrap="square" lIns="0" tIns="0" rIns="0" bIns="0" rtlCol="0" anchor="ctr"/>
+          <a:lstStyle/>
           <a:p>
             <a:pPr indent="0" marL="0">
               <a:buNone/>
@@ -4995,25 +5228,27 @@
                   <a:schemeClr val="tx2"/>
                 </a:solidFill>
               </a:rPr>
-              <a:t>Causa, valor reportado, esperado y diferencia.</a:t>
-            </a:r>
-            <a:endParaRPr lang="en-US" sz="1700" dirty="0"/>
-          </a:p>
-        </p:txBody>
-      </p:sp>
-      <p:sp>
-        <p:nvSpPr>
-          <p:cNvPr id="9" name="Círculo Criterios estandarizados"/>
+              <a:t>Es difícil explicar por qué una factura no cuadra.</a:t>
+            </a:r>
+            <a:endParaRPr lang="en-US" sz="1400" dirty="0"/>
+          </a:p>
+        </p:txBody>
+      </p:sp>
+      <p:sp>
+        <p:nvSpPr>
+          <p:cNvPr id="17" name="Prototipo Trazabilidad"/>
           <p:cNvSpPr/>
           <p:nvPr/>
         </p:nvSpPr>
         <p:spPr>
           <a:xfrm>
-            <a:off x="548640" y="3831336"/>
-            <a:ext cx="685800" cy="685800"/>
-          </a:xfrm>
-          <a:prstGeom prst="ellipse">
-            <a:avLst/>
+            <a:off x="7955280" y="2944368"/>
+            <a:ext cx="3703320" cy="914400"/>
+          </a:xfrm>
+          <a:prstGeom prst="roundRect">
+            <a:avLst>
+              <a:gd name="adj" fmla="val 10000"/>
+            </a:avLst>
           </a:prstGeom>
           <a:solidFill>
             <a:schemeClr val="accent1"/>
@@ -5026,9 +5261,70 @@
           </a:ln>
         </p:spPr>
       </p:sp>
+      <p:sp>
+        <p:nvSpPr>
+          <p:cNvPr id="18" name="Texto prototipo Trazabilidad"/>
+          <p:cNvSpPr txBox="1"/>
+          <p:nvPr/>
+        </p:nvSpPr>
+        <p:spPr>
+          <a:xfrm>
+            <a:off x="8138160" y="2944368"/>
+            <a:ext cx="3337560" cy="914400"/>
+          </a:xfrm>
+          <a:prstGeom prst="rect">
+            <a:avLst/>
+          </a:prstGeom>
+          <a:noFill/>
+          <a:ln/>
+        </p:spPr>
+        <p:txBody>
+          <a:bodyPr wrap="square" lIns="0" tIns="0" rIns="0" bIns="0" rtlCol="0" anchor="ctr"/>
+          <a:lstStyle/>
+          <a:p>
+            <a:pPr indent="0" marL="0">
+              <a:buNone/>
+            </a:pPr>
+            <a:r>
+              <a:rPr lang="en-US" sz="1400" dirty="0">
+                <a:solidFill>
+                  <a:schemeClr val="tx1"/>
+                </a:solidFill>
+              </a:rPr>
+              <a:t>Cada causa muestra el valor reportado, el esperado y la diferencia.</a:t>
+            </a:r>
+            <a:endParaRPr lang="en-US" sz="1400" dirty="0"/>
+          </a:p>
+        </p:txBody>
+      </p:sp>
+      <p:sp>
+        <p:nvSpPr>
+          <p:cNvPr id="19" name="Círculo Criterios uniformes"/>
+          <p:cNvSpPr/>
+          <p:nvPr/>
+        </p:nvSpPr>
+        <p:spPr>
+          <a:xfrm>
+            <a:off x="548640" y="4151376"/>
+            <a:ext cx="640080" cy="640080"/>
+          </a:xfrm>
+          <a:prstGeom prst="ellipse">
+            <a:avLst/>
+          </a:prstGeom>
+          <a:solidFill>
+            <a:schemeClr val="accent1"/>
+          </a:solidFill>
+          <a:ln w="12700">
+            <a:solidFill>
+              <a:schemeClr val="accent1"/>
+            </a:solidFill>
+            <a:prstDash val="solid"/>
+          </a:ln>
+        </p:spPr>
+      </p:sp>
       <p:pic>
         <p:nvPicPr>
-          <p:cNvPr id="10" name="Ícono Criterios estandarizados" descr="Criterios estandarizados">    </p:cNvPr>
+          <p:cNvPr id="20" name="Ícono Criterios uniformes" descr="Criterios uniformes">    </p:cNvPr>
           <p:cNvPicPr>
             <a:picLocks noChangeAspect="1"/>
           </p:cNvPicPr>
@@ -5042,8 +5338,8 @@
         </p:blipFill>
         <p:spPr>
           <a:xfrm>
-            <a:off x="722376" y="4005072"/>
-            <a:ext cx="338328" cy="338328"/>
+            <a:off x="708660" y="4311396"/>
+            <a:ext cx="320040" cy="320040"/>
           </a:xfrm>
           <a:prstGeom prst="rect">
             <a:avLst/>
@@ -5052,14 +5348,14 @@
       </p:pic>
       <p:sp>
         <p:nvSpPr>
-          <p:cNvPr id="11" name="Beneficio Criterios estandarizados"/>
+          <p:cNvPr id="21" name="Beneficio Criterios uniformes"/>
           <p:cNvSpPr txBox="1"/>
           <p:nvPr/>
         </p:nvSpPr>
         <p:spPr>
           <a:xfrm>
-            <a:off x="1463040" y="3785616"/>
-            <a:ext cx="4572000" cy="960120"/>
+            <a:off x="1371600" y="4014216"/>
+            <a:ext cx="2606040" cy="914400"/>
           </a:xfrm>
           <a:prstGeom prst="rect">
             <a:avLst/>
@@ -5068,7 +5364,7 @@
           <a:ln/>
         </p:spPr>
         <p:txBody>
-          <a:bodyPr wrap="square" lIns="0" tIns="0" rIns="0" bIns="0" rtlCol="0" anchor="t"/>
+          <a:bodyPr wrap="square" lIns="0" tIns="0" rIns="0" bIns="0" rtlCol="0" anchor="ctr"/>
           <a:lstStyle/>
           <a:p>
             <a:pPr indent="0" marL="0">
@@ -5080,10 +5376,59 @@
                   <a:schemeClr val="tx1"/>
                 </a:solidFill>
               </a:rPr>
-              <a:t>Criterios estandarizados</a:t>
+              <a:t>Criterios uniformes</a:t>
             </a:r>
             <a:endParaRPr lang="en-US" sz="1700" dirty="0"/>
           </a:p>
+        </p:txBody>
+      </p:sp>
+      <p:sp>
+        <p:nvSpPr>
+          <p:cNvPr id="22" name="Hoy Criterios uniformes"/>
+          <p:cNvSpPr/>
+          <p:nvPr/>
+        </p:nvSpPr>
+        <p:spPr>
+          <a:xfrm>
+            <a:off x="4160520" y="4014216"/>
+            <a:ext cx="3703320" cy="914400"/>
+          </a:xfrm>
+          <a:prstGeom prst="roundRect">
+            <a:avLst>
+              <a:gd name="adj" fmla="val 10000"/>
+            </a:avLst>
+          </a:prstGeom>
+          <a:solidFill>
+            <a:schemeClr val="bg2"/>
+          </a:solidFill>
+          <a:ln w="12700">
+            <a:solidFill>
+              <a:schemeClr val="bg2"/>
+            </a:solidFill>
+            <a:prstDash val="solid"/>
+          </a:ln>
+        </p:spPr>
+      </p:sp>
+      <p:sp>
+        <p:nvSpPr>
+          <p:cNvPr id="23" name="Texto hoy Criterios uniformes"/>
+          <p:cNvSpPr txBox="1"/>
+          <p:nvPr/>
+        </p:nvSpPr>
+        <p:spPr>
+          <a:xfrm>
+            <a:off x="4343400" y="4014216"/>
+            <a:ext cx="3337560" cy="914400"/>
+          </a:xfrm>
+          <a:prstGeom prst="rect">
+            <a:avLst/>
+          </a:prstGeom>
+          <a:noFill/>
+          <a:ln/>
+        </p:spPr>
+        <p:txBody>
+          <a:bodyPr wrap="square" lIns="0" tIns="0" rIns="0" bIns="0" rtlCol="0" anchor="ctr"/>
+          <a:lstStyle/>
           <a:p>
             <a:pPr indent="0" marL="0">
               <a:buNone/>
@@ -5094,25 +5439,27 @@
                   <a:schemeClr val="tx2"/>
                 </a:solidFill>
               </a:rPr>
-              <a:t>Las mismas reglas para todos los meses y analistas.</a:t>
-            </a:r>
-            <a:endParaRPr lang="en-US" sz="1700" dirty="0"/>
-          </a:p>
-        </p:txBody>
-      </p:sp>
-      <p:sp>
-        <p:nvSpPr>
-          <p:cNvPr id="12" name="Círculo Riesgos detectados a tiempo"/>
+              <a:t>El resultado depende de quién revisa.</a:t>
+            </a:r>
+            <a:endParaRPr lang="en-US" sz="1400" dirty="0"/>
+          </a:p>
+        </p:txBody>
+      </p:sp>
+      <p:sp>
+        <p:nvSpPr>
+          <p:cNvPr id="24" name="Prototipo Criterios uniformes"/>
           <p:cNvSpPr/>
           <p:nvPr/>
         </p:nvSpPr>
         <p:spPr>
           <a:xfrm>
-            <a:off x="548640" y="4992624"/>
-            <a:ext cx="685800" cy="685800"/>
-          </a:xfrm>
-          <a:prstGeom prst="ellipse">
-            <a:avLst/>
+            <a:off x="7955280" y="4014216"/>
+            <a:ext cx="3703320" cy="914400"/>
+          </a:xfrm>
+          <a:prstGeom prst="roundRect">
+            <a:avLst>
+              <a:gd name="adj" fmla="val 10000"/>
+            </a:avLst>
           </a:prstGeom>
           <a:solidFill>
             <a:schemeClr val="accent1"/>
@@ -5125,9 +5472,70 @@
           </a:ln>
         </p:spPr>
       </p:sp>
+      <p:sp>
+        <p:nvSpPr>
+          <p:cNvPr id="25" name="Texto prototipo Criterios uniformes"/>
+          <p:cNvSpPr txBox="1"/>
+          <p:nvPr/>
+        </p:nvSpPr>
+        <p:spPr>
+          <a:xfrm>
+            <a:off x="8138160" y="4014216"/>
+            <a:ext cx="3337560" cy="914400"/>
+          </a:xfrm>
+          <a:prstGeom prst="rect">
+            <a:avLst/>
+          </a:prstGeom>
+          <a:noFill/>
+          <a:ln/>
+        </p:spPr>
+        <p:txBody>
+          <a:bodyPr wrap="square" lIns="0" tIns="0" rIns="0" bIns="0" rtlCol="0" anchor="ctr"/>
+          <a:lstStyle/>
+          <a:p>
+            <a:pPr indent="0" marL="0">
+              <a:buNone/>
+            </a:pPr>
+            <a:r>
+              <a:rPr lang="en-US" sz="1400" dirty="0">
+                <a:solidFill>
+                  <a:schemeClr val="tx1"/>
+                </a:solidFill>
+              </a:rPr>
+              <a:t>Las mismas reglas se aplican en cada conciliación.</a:t>
+            </a:r>
+            <a:endParaRPr lang="en-US" sz="1400" dirty="0"/>
+          </a:p>
+        </p:txBody>
+      </p:sp>
+      <p:sp>
+        <p:nvSpPr>
+          <p:cNvPr id="26" name="Círculo Menos reprocesos"/>
+          <p:cNvSpPr/>
+          <p:nvPr/>
+        </p:nvSpPr>
+        <p:spPr>
+          <a:xfrm>
+            <a:off x="548640" y="5221224"/>
+            <a:ext cx="640080" cy="640080"/>
+          </a:xfrm>
+          <a:prstGeom prst="ellipse">
+            <a:avLst/>
+          </a:prstGeom>
+          <a:solidFill>
+            <a:schemeClr val="accent1"/>
+          </a:solidFill>
+          <a:ln w="12700">
+            <a:solidFill>
+              <a:schemeClr val="accent1"/>
+            </a:solidFill>
+            <a:prstDash val="solid"/>
+          </a:ln>
+        </p:spPr>
+      </p:sp>
       <p:pic>
         <p:nvPicPr>
-          <p:cNvPr id="13" name="Ícono Riesgos detectados a tiempo" descr="Riesgos detectados a tiempo">    </p:cNvPr>
+          <p:cNvPr id="27" name="Ícono Menos reprocesos" descr="Menos reprocesos">    </p:cNvPr>
           <p:cNvPicPr>
             <a:picLocks noChangeAspect="1"/>
           </p:cNvPicPr>
@@ -5141,8 +5549,8 @@
         </p:blipFill>
         <p:spPr>
           <a:xfrm>
-            <a:off x="722376" y="5166360"/>
-            <a:ext cx="338328" cy="338328"/>
+            <a:off x="708660" y="5381244"/>
+            <a:ext cx="320040" cy="320040"/>
           </a:xfrm>
           <a:prstGeom prst="rect">
             <a:avLst/>
@@ -5151,14 +5559,14 @@
       </p:pic>
       <p:sp>
         <p:nvSpPr>
-          <p:cNvPr id="14" name="Beneficio Riesgos detectados a tiempo"/>
+          <p:cNvPr id="28" name="Beneficio Menos reprocesos"/>
           <p:cNvSpPr txBox="1"/>
           <p:nvPr/>
         </p:nvSpPr>
         <p:spPr>
           <a:xfrm>
-            <a:off x="1463040" y="4946904"/>
-            <a:ext cx="4572000" cy="960120"/>
+            <a:off x="1371600" y="5084064"/>
+            <a:ext cx="2606040" cy="914400"/>
           </a:xfrm>
           <a:prstGeom prst="rect">
             <a:avLst/>
@@ -5167,7 +5575,7 @@
           <a:ln/>
         </p:spPr>
         <p:txBody>
-          <a:bodyPr wrap="square" lIns="0" tIns="0" rIns="0" bIns="0" rtlCol="0" anchor="t"/>
+          <a:bodyPr wrap="square" lIns="0" tIns="0" rIns="0" bIns="0" rtlCol="0" anchor="ctr"/>
           <a:lstStyle/>
           <a:p>
             <a:pPr indent="0" marL="0">
@@ -5179,40 +5587,26 @@
                   <a:schemeClr val="tx1"/>
                 </a:solidFill>
               </a:rPr>
-              <a:t>Riesgos detectados a tiempo</a:t>
+              <a:t>Menos reprocesos</a:t>
             </a:r>
             <a:endParaRPr lang="en-US" sz="1700" dirty="0"/>
           </a:p>
-          <a:p>
-            <a:pPr indent="0" marL="0">
-              <a:buNone/>
-            </a:pPr>
-            <a:r>
-              <a:rPr lang="en-US" sz="1400" dirty="0">
-                <a:solidFill>
-                  <a:schemeClr val="tx2"/>
-                </a:solidFill>
-              </a:rPr>
-              <a:t>Doble pago, IVA descontable mal soportado, pasivos sin registrar y errores de corte.</a:t>
-            </a:r>
-            <a:endParaRPr lang="en-US" sz="1700" dirty="0"/>
-          </a:p>
-        </p:txBody>
-      </p:sp>
-      <p:sp>
-        <p:nvSpPr>
-          <p:cNvPr id="15" name="Panel siguientes pasos"/>
+        </p:txBody>
+      </p:sp>
+      <p:sp>
+        <p:nvSpPr>
+          <p:cNvPr id="29" name="Hoy Menos reprocesos"/>
           <p:cNvSpPr/>
           <p:nvPr/>
         </p:nvSpPr>
         <p:spPr>
           <a:xfrm>
-            <a:off x="6492240" y="1463040"/>
-            <a:ext cx="5166360" cy="4617720"/>
+            <a:off x="4160520" y="5084064"/>
+            <a:ext cx="3703320" cy="914400"/>
           </a:xfrm>
           <a:prstGeom prst="roundRect">
             <a:avLst>
-              <a:gd name="adj" fmla="val 2376"/>
+              <a:gd name="adj" fmla="val 10000"/>
             </a:avLst>
           </a:prstGeom>
           <a:solidFill>
@@ -5228,14 +5622,14 @@
       </p:sp>
       <p:sp>
         <p:nvSpPr>
-          <p:cNvPr id="16" name="Encabezado siguientes pasos"/>
+          <p:cNvPr id="30" name="Texto hoy Menos reprocesos"/>
           <p:cNvSpPr txBox="1"/>
           <p:nvPr/>
         </p:nvSpPr>
         <p:spPr>
           <a:xfrm>
-            <a:off x="6812280" y="1691640"/>
-            <a:ext cx="4572000" cy="457200"/>
+            <a:off x="4343400" y="5084064"/>
+            <a:ext cx="3337560" cy="914400"/>
           </a:xfrm>
           <a:prstGeom prst="rect">
             <a:avLst/>
@@ -5251,30 +5645,32 @@
               <a:buNone/>
             </a:pPr>
             <a:r>
-              <a:rPr lang="en-US" sz="2000" b="1" dirty="0">
-                <a:solidFill>
-                  <a:schemeClr val="tx1"/>
-                </a:solidFill>
-              </a:rPr>
-              <a:t>Siguientes pasos</a:t>
-            </a:r>
-            <a:endParaRPr lang="en-US" sz="2000" dirty="0"/>
-          </a:p>
-        </p:txBody>
-      </p:sp>
-      <p:sp>
-        <p:nvSpPr>
-          <p:cNvPr id="17" name="Número paso 1"/>
+              <a:rPr lang="en-US" sz="1400" dirty="0">
+                <a:solidFill>
+                  <a:schemeClr val="tx2"/>
+                </a:solidFill>
+              </a:rPr>
+              <a:t>Las diferencias se detectan tarde.</a:t>
+            </a:r>
+            <a:endParaRPr lang="en-US" sz="1400" dirty="0"/>
+          </a:p>
+        </p:txBody>
+      </p:sp>
+      <p:sp>
+        <p:nvSpPr>
+          <p:cNvPr id="31" name="Prototipo Menos reprocesos"/>
           <p:cNvSpPr/>
           <p:nvPr/>
         </p:nvSpPr>
         <p:spPr>
           <a:xfrm>
-            <a:off x="6812280" y="2331720"/>
-            <a:ext cx="457200" cy="457200"/>
-          </a:xfrm>
-          <a:prstGeom prst="ellipse">
-            <a:avLst/>
+            <a:off x="7955280" y="5084064"/>
+            <a:ext cx="3703320" cy="914400"/>
+          </a:xfrm>
+          <a:prstGeom prst="roundRect">
+            <a:avLst>
+              <a:gd name="adj" fmla="val 10000"/>
+            </a:avLst>
           </a:prstGeom>
           <a:solidFill>
             <a:schemeClr val="accent1"/>
@@ -5289,14 +5685,14 @@
       </p:sp>
       <p:sp>
         <p:nvSpPr>
-          <p:cNvPr id="18" name="Cifra paso 1"/>
+          <p:cNvPr id="32" name="Texto prototipo Menos reprocesos"/>
           <p:cNvSpPr txBox="1"/>
           <p:nvPr/>
         </p:nvSpPr>
         <p:spPr>
           <a:xfrm>
-            <a:off x="6812280" y="2331720"/>
-            <a:ext cx="457200" cy="457200"/>
+            <a:off x="8138160" y="5084064"/>
+            <a:ext cx="3337560" cy="914400"/>
           </a:xfrm>
           <a:prstGeom prst="rect">
             <a:avLst/>
@@ -5308,345 +5704,18 @@
           <a:bodyPr wrap="square" lIns="0" tIns="0" rIns="0" bIns="0" rtlCol="0" anchor="ctr"/>
           <a:lstStyle/>
           <a:p>
-            <a:pPr algn="ctr" indent="0" marL="0">
-              <a:buNone/>
-            </a:pPr>
-            <a:r>
-              <a:rPr lang="en-US" sz="1500" b="1" dirty="0">
+            <a:pPr indent="0" marL="0">
+              <a:buNone/>
+            </a:pPr>
+            <a:r>
+              <a:rPr lang="en-US" sz="1400" dirty="0">
                 <a:solidFill>
                   <a:schemeClr val="tx1"/>
                 </a:solidFill>
               </a:rPr>
-              <a:t>1</a:t>
-            </a:r>
-            <a:endParaRPr lang="en-US" sz="1500" dirty="0"/>
-          </a:p>
-        </p:txBody>
-      </p:sp>
-      <p:sp>
-        <p:nvSpPr>
-          <p:cNvPr id="19" name="Texto paso 1"/>
-          <p:cNvSpPr txBox="1"/>
-          <p:nvPr/>
-        </p:nvSpPr>
-        <p:spPr>
-          <a:xfrm>
-            <a:off x="7452360" y="2286000"/>
-            <a:ext cx="3977640" cy="777240"/>
-          </a:xfrm>
-          <a:prstGeom prst="rect">
-            <a:avLst/>
-          </a:prstGeom>
-          <a:noFill/>
-          <a:ln/>
-        </p:spPr>
-        <p:txBody>
-          <a:bodyPr wrap="square" lIns="0" tIns="0" rIns="0" bIns="0" rtlCol="0" anchor="t"/>
-          <a:lstStyle/>
-          <a:p>
-            <a:pPr indent="0" marL="0">
-              <a:buNone/>
-            </a:pPr>
-            <a:r>
-              <a:rPr lang="en-US" sz="1500" dirty="0">
-                <a:solidFill>
-                  <a:schemeClr val="tx1"/>
-                </a:solidFill>
-              </a:rPr>
-              <a:t>Validar las reglas con el equipo funcional (por ejemplo, el tratamiento del estado pendiente).</a:t>
-            </a:r>
-            <a:endParaRPr lang="en-US" sz="1500" dirty="0"/>
-          </a:p>
-        </p:txBody>
-      </p:sp>
-      <p:sp>
-        <p:nvSpPr>
-          <p:cNvPr id="20" name="Número paso 2"/>
-          <p:cNvSpPr/>
-          <p:nvPr/>
-        </p:nvSpPr>
-        <p:spPr>
-          <a:xfrm>
-            <a:off x="6812280" y="3227832"/>
-            <a:ext cx="457200" cy="457200"/>
-          </a:xfrm>
-          <a:prstGeom prst="ellipse">
-            <a:avLst/>
-          </a:prstGeom>
-          <a:solidFill>
-            <a:schemeClr val="accent1"/>
-          </a:solidFill>
-          <a:ln w="12700">
-            <a:solidFill>
-              <a:schemeClr val="accent1"/>
-            </a:solidFill>
-            <a:prstDash val="solid"/>
-          </a:ln>
-        </p:spPr>
-      </p:sp>
-      <p:sp>
-        <p:nvSpPr>
-          <p:cNvPr id="21" name="Cifra paso 2"/>
-          <p:cNvSpPr txBox="1"/>
-          <p:nvPr/>
-        </p:nvSpPr>
-        <p:spPr>
-          <a:xfrm>
-            <a:off x="6812280" y="3227832"/>
-            <a:ext cx="457200" cy="457200"/>
-          </a:xfrm>
-          <a:prstGeom prst="rect">
-            <a:avLst/>
-          </a:prstGeom>
-          <a:noFill/>
-          <a:ln/>
-        </p:spPr>
-        <p:txBody>
-          <a:bodyPr wrap="square" lIns="0" tIns="0" rIns="0" bIns="0" rtlCol="0" anchor="ctr"/>
-          <a:lstStyle/>
-          <a:p>
-            <a:pPr algn="ctr" indent="0" marL="0">
-              <a:buNone/>
-            </a:pPr>
-            <a:r>
-              <a:rPr lang="en-US" sz="1500" b="1" dirty="0">
-                <a:solidFill>
-                  <a:schemeClr val="tx1"/>
-                </a:solidFill>
-              </a:rPr>
-              <a:t>2</a:t>
-            </a:r>
-            <a:endParaRPr lang="en-US" sz="1500" dirty="0"/>
-          </a:p>
-        </p:txBody>
-      </p:sp>
-      <p:sp>
-        <p:nvSpPr>
-          <p:cNvPr id="22" name="Texto paso 2"/>
-          <p:cNvSpPr txBox="1"/>
-          <p:nvPr/>
-        </p:nvSpPr>
-        <p:spPr>
-          <a:xfrm>
-            <a:off x="7452360" y="3182112"/>
-            <a:ext cx="3977640" cy="777240"/>
-          </a:xfrm>
-          <a:prstGeom prst="rect">
-            <a:avLst/>
-          </a:prstGeom>
-          <a:noFill/>
-          <a:ln/>
-        </p:spPr>
-        <p:txBody>
-          <a:bodyPr wrap="square" lIns="0" tIns="0" rIns="0" bIns="0" rtlCol="0" anchor="t"/>
-          <a:lstStyle/>
-          <a:p>
-            <a:pPr indent="0" marL="0">
-              <a:buNone/>
-            </a:pPr>
-            <a:r>
-              <a:rPr lang="en-US" sz="1500" dirty="0">
-                <a:solidFill>
-                  <a:schemeClr val="tx1"/>
-                </a:solidFill>
-              </a:rPr>
-              <a:t>Guardar el histórico mensual y exportar resultados a Excel.</a:t>
-            </a:r>
-            <a:endParaRPr lang="en-US" sz="1500" dirty="0"/>
-          </a:p>
-        </p:txBody>
-      </p:sp>
-      <p:sp>
-        <p:nvSpPr>
-          <p:cNvPr id="23" name="Número paso 3"/>
-          <p:cNvSpPr/>
-          <p:nvPr/>
-        </p:nvSpPr>
-        <p:spPr>
-          <a:xfrm>
-            <a:off x="6812280" y="4123944"/>
-            <a:ext cx="457200" cy="457200"/>
-          </a:xfrm>
-          <a:prstGeom prst="ellipse">
-            <a:avLst/>
-          </a:prstGeom>
-          <a:solidFill>
-            <a:schemeClr val="accent1"/>
-          </a:solidFill>
-          <a:ln w="12700">
-            <a:solidFill>
-              <a:schemeClr val="accent1"/>
-            </a:solidFill>
-            <a:prstDash val="solid"/>
-          </a:ln>
-        </p:spPr>
-      </p:sp>
-      <p:sp>
-        <p:nvSpPr>
-          <p:cNvPr id="24" name="Cifra paso 3"/>
-          <p:cNvSpPr txBox="1"/>
-          <p:nvPr/>
-        </p:nvSpPr>
-        <p:spPr>
-          <a:xfrm>
-            <a:off x="6812280" y="4123944"/>
-            <a:ext cx="457200" cy="457200"/>
-          </a:xfrm>
-          <a:prstGeom prst="rect">
-            <a:avLst/>
-          </a:prstGeom>
-          <a:noFill/>
-          <a:ln/>
-        </p:spPr>
-        <p:txBody>
-          <a:bodyPr wrap="square" lIns="0" tIns="0" rIns="0" bIns="0" rtlCol="0" anchor="ctr"/>
-          <a:lstStyle/>
-          <a:p>
-            <a:pPr algn="ctr" indent="0" marL="0">
-              <a:buNone/>
-            </a:pPr>
-            <a:r>
-              <a:rPr lang="en-US" sz="1500" b="1" dirty="0">
-                <a:solidFill>
-                  <a:schemeClr val="tx1"/>
-                </a:solidFill>
-              </a:rPr>
-              <a:t>3</a:t>
-            </a:r>
-            <a:endParaRPr lang="en-US" sz="1500" dirty="0"/>
-          </a:p>
-        </p:txBody>
-      </p:sp>
-      <p:sp>
-        <p:nvSpPr>
-          <p:cNvPr id="25" name="Texto paso 3"/>
-          <p:cNvSpPr txBox="1"/>
-          <p:nvPr/>
-        </p:nvSpPr>
-        <p:spPr>
-          <a:xfrm>
-            <a:off x="7452360" y="4078224"/>
-            <a:ext cx="3977640" cy="777240"/>
-          </a:xfrm>
-          <a:prstGeom prst="rect">
-            <a:avLst/>
-          </a:prstGeom>
-          <a:noFill/>
-          <a:ln/>
-        </p:spPr>
-        <p:txBody>
-          <a:bodyPr wrap="square" lIns="0" tIns="0" rIns="0" bIns="0" rtlCol="0" anchor="t"/>
-          <a:lstStyle/>
-          <a:p>
-            <a:pPr indent="0" marL="0">
-              <a:buNone/>
-            </a:pPr>
-            <a:r>
-              <a:rPr lang="en-US" sz="1500" dirty="0">
-                <a:solidFill>
-                  <a:schemeClr val="tx1"/>
-                </a:solidFill>
-              </a:rPr>
-              <a:t>Incorporar ReteIVA, ReteICA y la validación del NIT.</a:t>
-            </a:r>
-            <a:endParaRPr lang="en-US" sz="1500" dirty="0"/>
-          </a:p>
-        </p:txBody>
-      </p:sp>
-      <p:sp>
-        <p:nvSpPr>
-          <p:cNvPr id="26" name="Número paso 4"/>
-          <p:cNvSpPr/>
-          <p:nvPr/>
-        </p:nvSpPr>
-        <p:spPr>
-          <a:xfrm>
-            <a:off x="6812280" y="5020056"/>
-            <a:ext cx="457200" cy="457200"/>
-          </a:xfrm>
-          <a:prstGeom prst="ellipse">
-            <a:avLst/>
-          </a:prstGeom>
-          <a:solidFill>
-            <a:schemeClr val="accent1"/>
-          </a:solidFill>
-          <a:ln w="12700">
-            <a:solidFill>
-              <a:schemeClr val="accent1"/>
-            </a:solidFill>
-            <a:prstDash val="solid"/>
-          </a:ln>
-        </p:spPr>
-      </p:sp>
-      <p:sp>
-        <p:nvSpPr>
-          <p:cNvPr id="27" name="Cifra paso 4"/>
-          <p:cNvSpPr txBox="1"/>
-          <p:nvPr/>
-        </p:nvSpPr>
-        <p:spPr>
-          <a:xfrm>
-            <a:off x="6812280" y="5020056"/>
-            <a:ext cx="457200" cy="457200"/>
-          </a:xfrm>
-          <a:prstGeom prst="rect">
-            <a:avLst/>
-          </a:prstGeom>
-          <a:noFill/>
-          <a:ln/>
-        </p:spPr>
-        <p:txBody>
-          <a:bodyPr wrap="square" lIns="0" tIns="0" rIns="0" bIns="0" rtlCol="0" anchor="ctr"/>
-          <a:lstStyle/>
-          <a:p>
-            <a:pPr algn="ctr" indent="0" marL="0">
-              <a:buNone/>
-            </a:pPr>
-            <a:r>
-              <a:rPr lang="en-US" sz="1500" b="1" dirty="0">
-                <a:solidFill>
-                  <a:schemeClr val="tx1"/>
-                </a:solidFill>
-              </a:rPr>
-              <a:t>4</a:t>
-            </a:r>
-            <a:endParaRPr lang="en-US" sz="1500" dirty="0"/>
-          </a:p>
-        </p:txBody>
-      </p:sp>
-      <p:sp>
-        <p:nvSpPr>
-          <p:cNvPr id="28" name="Texto paso 4"/>
-          <p:cNvSpPr txBox="1"/>
-          <p:nvPr/>
-        </p:nvSpPr>
-        <p:spPr>
-          <a:xfrm>
-            <a:off x="7452360" y="4974336"/>
-            <a:ext cx="3977640" cy="777240"/>
-          </a:xfrm>
-          <a:prstGeom prst="rect">
-            <a:avLst/>
-          </a:prstGeom>
-          <a:noFill/>
-          <a:ln/>
-        </p:spPr>
-        <p:txBody>
-          <a:bodyPr wrap="square" lIns="0" tIns="0" rIns="0" bIns="0" rtlCol="0" anchor="t"/>
-          <a:lstStyle/>
-          <a:p>
-            <a:pPr indent="0" marL="0">
-              <a:buNone/>
-            </a:pPr>
-            <a:r>
-              <a:rPr lang="en-US" sz="1500" dirty="0">
-                <a:solidFill>
-                  <a:schemeClr val="tx1"/>
-                </a:solidFill>
-              </a:rPr>
-              <a:t>Integrar con el ERP para eliminar la carga manual de archivos.</a:t>
-            </a:r>
-            <a:endParaRPr lang="en-US" sz="1500" dirty="0"/>
+              <a:t>Duplicadas, sin contabilizar y pendientes quedan visibles de inmediato.</a:t>
+            </a:r>
+            <a:endParaRPr lang="en-US" sz="1400" dirty="0"/>
           </a:p>
         </p:txBody>
       </p:sp>

</xml_diff>

<commit_message>
docs(presentacion): nueva paleta y captura actualizada del prototipo
Co-Authored-By: Claude Opus 5.5 <noreply@anthropic.com>
</commit_message>
<xml_diff>
--- a/docs/presentacion/presentacion-conciliador.pptx
+++ b/docs/presentacion/presentacion-conciliador.pptx
@@ -111,27 +111,27 @@
   <p:extLst>
     <p:ext uri="{521415D9-36F7-43E2-AB2F-B90AF26B5E84}">
       <p14:sectionLst xmlns:p14="http://schemas.microsoft.com/office/powerpoint/2010/main">
-        <p14:section name="Problema" id="{cfc54839-e2ff-bd4b-4dbc-4b3d4b0f5cac}">
+        <p14:section name="Problema" id="{19b4b3d4-461a-d8cf-114f-fd5e048489d9}">
           <p14:sldIdLst>
             <p14:sldId id="256"/>
           </p14:sldIdLst>
         </p14:section>
-        <p14:section name="Solución" id="{be9f0658-4da1-934b-1116-28f95475f5b0}">
+        <p14:section name="Solución" id="{9bfcb2db-939c-8054-16fd-47a90e73170c}">
           <p14:sldIdLst>
             <p14:sldId id="257"/>
           </p14:sldIdLst>
         </p14:section>
-        <p14:section name="Flujo" id="{01cbd5ce-5001-01db-a2ab-476c34b76a0f}">
+        <p14:section name="Flujo" id="{9ac2233f-c893-492e-05b2-8f94e161f84c}">
           <p14:sldIdLst>
             <p14:sldId id="258"/>
           </p14:sldIdLst>
         </p14:section>
-        <p14:section name="Resultados" id="{9e275633-0964-276b-d29a-7f84fae28323}">
+        <p14:section name="Resultados" id="{991c2a70-fa8b-5a07-9386-d5a94ef088de}">
           <p14:sldIdLst>
             <p14:sldId id="259"/>
           </p14:sldIdLst>
         </p14:section>
-        <p14:section name="Beneficios" id="{e4697d09-1904-3d74-5141-54f477b633c8}">
+        <p14:section name="Beneficios" id="{534e346d-25e5-ccda-c338-b11e0d056591}">
           <p14:sldIdLst>
             <p14:sldId id="260"/>
           </p14:sldIdLst>
@@ -159,7 +159,7 @@
             <a:pPr>
               <a:defRPr sz="1400" b="0" i="0" u="none" strike="noStrike">
                 <a:solidFill>
-                  <a:srgbClr val="1F1F1F"/>
+                  <a:srgbClr val="2C2A29"/>
                 </a:solidFill>
                 <a:latin typeface="+mn-lt"/>
               </a:defRPr>
@@ -167,7 +167,7 @@
             <a:r>
               <a:rPr sz="1400" b="0" i="0" u="none" strike="noStrike">
                 <a:solidFill>
-                  <a:srgbClr val="1F1F1F"/>
+                  <a:srgbClr val="2C2A29"/>
                 </a:solidFill>
                 <a:latin typeface="+mn-lt"/>
               </a:rPr>
@@ -216,7 +216,7 @@
                 <a:pPr>
                   <a:defRPr b="0" i="0" strike="noStrike" sz="1200" u="none">
                     <a:solidFill>
-                      <a:srgbClr val="1F1F1F"/>
+                      <a:srgbClr val="2C2A29"/>
                     </a:solidFill>
                     <a:latin typeface="+mn-lt"/>
                   </a:defRPr>
@@ -302,7 +302,7 @@
               <a:pPr>
                 <a:defRPr b="0" i="0" strike="noStrike" sz="1200" u="none">
                   <a:solidFill>
-                    <a:srgbClr val="1F1F1F"/>
+                    <a:srgbClr val="2C2A29"/>
                   </a:solidFill>
                   <a:latin typeface="+mn-lt"/>
                 </a:defRPr>
@@ -350,7 +350,7 @@
             <a:pPr>
               <a:defRPr sz="1200" b="0" i="0" u="none" strike="noStrike">
                 <a:solidFill>
-                  <a:srgbClr val="4A4A4A"/>
+                  <a:srgbClr val="595755"/>
                 </a:solidFill>
                 <a:latin typeface="+mn-lt"/>
               </a:defRPr>
@@ -5777,19 +5777,19 @@
   <a:themeElements>
     <a:clrScheme name="Conciliador">
       <a:dk1>
-        <a:srgbClr val="1F1F1F"/>
+        <a:srgbClr val="2C2A29"/>
       </a:dk1>
       <a:lt1>
         <a:srgbClr val="FFFFFF"/>
       </a:lt1>
       <a:dk2>
-        <a:srgbClr val="4A4A4A"/>
+        <a:srgbClr val="595755"/>
       </a:dk2>
       <a:lt2>
-        <a:srgbClr val="F4F4F4"/>
+        <a:srgbClr val="F7F7F7"/>
       </a:lt2>
       <a:accent1>
-        <a:srgbClr val="FFD100"/>
+        <a:srgbClr val="FDDA24"/>
       </a:accent1>
       <a:accent2>
         <a:srgbClr val="B3261E"/>

</xml_diff>

<commit_message>
fix(presentacion): gráfico de causas legible en cualquier visor (barras con nombre de cada causa)
Co-Authored-By: Claude Opus 5.5 <noreply@anthropic.com>
</commit_message>
<xml_diff>
--- a/docs/presentacion/presentacion-conciliador.pptx
+++ b/docs/presentacion/presentacion-conciliador.pptx
@@ -111,27 +111,27 @@
   <p:extLst>
     <p:ext uri="{521415D9-36F7-43E2-AB2F-B90AF26B5E84}">
       <p14:sectionLst xmlns:p14="http://schemas.microsoft.com/office/powerpoint/2010/main">
-        <p14:section name="Problema" id="{19b4b3d4-461a-d8cf-114f-fd5e048489d9}">
+        <p14:section name="Problema" id="{950aa038-b966-8d64-3eda-5caf6d646016}">
           <p14:sldIdLst>
             <p14:sldId id="256"/>
           </p14:sldIdLst>
         </p14:section>
-        <p14:section name="Solución" id="{9bfcb2db-939c-8054-16fd-47a90e73170c}">
+        <p14:section name="Solución" id="{03fbbf10-585d-29b3-6c8b-57e6b261db6a}">
           <p14:sldIdLst>
             <p14:sldId id="257"/>
           </p14:sldIdLst>
         </p14:section>
-        <p14:section name="Flujo" id="{9ac2233f-c893-492e-05b2-8f94e161f84c}">
+        <p14:section name="Flujo" id="{5993489e-674f-c5a0-bfd9-91439bd41b09}">
           <p14:sldIdLst>
             <p14:sldId id="258"/>
           </p14:sldIdLst>
         </p14:section>
-        <p14:section name="Resultados" id="{991c2a70-fa8b-5a07-9386-d5a94ef088de}">
+        <p14:section name="Resultados" id="{444e6589-fa6c-573b-a8c3-0bc9ebaf6682}">
           <p14:sldIdLst>
             <p14:sldId id="259"/>
           </p14:sldIdLst>
         </p14:section>
-        <p14:section name="Beneficios" id="{534e346d-25e5-ccda-c338-b11e0d056591}">
+        <p14:section name="Beneficios" id="{c3986134-8dac-941a-328f-5951f7a85f11}">
           <p14:sldIdLst>
             <p14:sldId id="260"/>
           </p14:sldIdLst>
@@ -143,290 +143,6 @@
     </p:ext>
   </p:extLst>
 </p:presentation>
-</file>
-
-<file path=ppt/charts/chart1.xml><?xml version="1.0" encoding="utf-8"?>
-<c:chartSpace xmlns:c="http://schemas.openxmlformats.org/drawingml/2006/chart" xmlns:a="http://schemas.openxmlformats.org/drawingml/2006/main" xmlns:r="http://schemas.openxmlformats.org/officeDocument/2006/relationships">
-  <c:date1904 val="0"/>
-  <c:roundedCorners val="1"/>
-  <c:chart>
-    <c:title>
-      <c:tx>
-        <c:rich>
-          <a:bodyPr/>
-          <a:lstStyle/>
-          <a:p>
-            <a:pPr>
-              <a:defRPr sz="1400" b="0" i="0" u="none" strike="noStrike">
-                <a:solidFill>
-                  <a:srgbClr val="2C2A29"/>
-                </a:solidFill>
-                <a:latin typeface="+mn-lt"/>
-              </a:defRPr>
-            </a:pPr>
-            <a:r>
-              <a:rPr sz="1400" b="0" i="0" u="none" strike="noStrike">
-                <a:solidFill>
-                  <a:srgbClr val="2C2A29"/>
-                </a:solidFill>
-                <a:latin typeface="+mn-lt"/>
-              </a:rPr>
-              <a:t>Inconsistencias por causa (número de facturas)</a:t>
-            </a:r>
-          </a:p>
-        </c:rich>
-      </c:tx>
-      <c:layout/>
-      <c:overlay val="0"/>
-    </c:title>
-    <c:autoTitleDeleted val="0"/>
-    <c:plotArea>
-      <c:layout/>
-      <c:barChart>
-        <c:barDir val="bar"/>
-        <c:grouping val="clustered"/>
-        <c:varyColors val="0"/>
-        <c:ser>
-          <c:idx val="0"/>
-          <c:order val="0"/>
-          <c:tx>
-            <c:strRef>
-              <c:f>Sheet1!$B$1</c:f>
-              <c:strCache>
-                <c:ptCount val="1"/>
-                <c:pt idx="0">
-                  <c:v>Facturas</c:v>
-                </c:pt>
-              </c:strCache>
-            </c:strRef>
-          </c:tx>
-          <c:spPr>
-            <a:solidFill>
-              <a:srgbClr val="B3261E"/>
-            </a:solidFill>
-            <a:effectLst/>
-          </c:spPr>
-          <c:invertIfNegative val="0"/>
-          <c:dLbls>
-            <c:numFmt formatCode="#,##0" sourceLinked="0"/>
-            <c:txPr>
-              <a:bodyPr/>
-              <a:lstStyle/>
-              <a:p>
-                <a:pPr>
-                  <a:defRPr b="0" i="0" strike="noStrike" sz="1200" u="none">
-                    <a:solidFill>
-                      <a:srgbClr val="2C2A29"/>
-                    </a:solidFill>
-                    <a:latin typeface="+mn-lt"/>
-                  </a:defRPr>
-                </a:pPr>
-              </a:p>
-            </c:txPr>
-            <c:showLegendKey val="0"/>
-            <c:showVal val="1"/>
-            <c:showCatName val="0"/>
-            <c:showSerName val="0"/>
-            <c:showPercent val="0"/>
-            <c:showBubbleSize val="0"/>
-            <c:showLeaderLines val="0"/>
-          </c:dLbls>
-          <c:cat>
-            <c:multiLvlStrRef>
-              <c:f>Sheet1!$A$2:$A$8</c:f>
-              <c:multiLvlStrCache>
-                <c:ptCount val="7"/>
-                <c:lvl>
-                  <c:pt idx="0">
-                    <c:v>Valor contabilizado diferente</c:v>
-                  </c:pt>
-                  <c:pt idx="1">
-                    <c:v>IVA mal calculado</c:v>
-                  </c:pt>
-                  <c:pt idx="2">
-                    <c:v>Contabilización pendiente</c:v>
-                  </c:pt>
-                  <c:pt idx="3">
-                    <c:v>Total no cuadra</c:v>
-                  </c:pt>
-                  <c:pt idx="4">
-                    <c:v>Campo obligatorio vacío</c:v>
-                  </c:pt>
-                  <c:pt idx="5">
-                    <c:v>Sin registro contable</c:v>
-                  </c:pt>
-                  <c:pt idx="6">
-                    <c:v>Factura duplicada</c:v>
-                  </c:pt>
-                </c:lvl>
-              </c:multiLvlStrCache>
-            </c:multiLvlStrRef>
-          </c:cat>
-          <c:val>
-            <c:numRef>
-              <c:f>Sheet1!$B$2:$B$8</c:f>
-              <c:numCache>
-                <c:formatCode>General</c:formatCode>
-                <c:ptCount val="7"/>
-                <c:pt idx="0">
-                  <c:v>2</c:v>
-                </c:pt>
-                <c:pt idx="1">
-                  <c:v>2</c:v>
-                </c:pt>
-                <c:pt idx="2">
-                  <c:v>3</c:v>
-                </c:pt>
-                <c:pt idx="3">
-                  <c:v>3</c:v>
-                </c:pt>
-                <c:pt idx="4">
-                  <c:v>3</c:v>
-                </c:pt>
-                <c:pt idx="5">
-                  <c:v>4</c:v>
-                </c:pt>
-                <c:pt idx="6">
-                  <c:v>4</c:v>
-                </c:pt>
-              </c:numCache>
-            </c:numRef>
-          </c:val>
-        </c:ser>
-        <c:dLbls>
-          <c:numFmt formatCode="#,##0" sourceLinked="0"/>
-          <c:txPr>
-            <a:bodyPr/>
-            <a:lstStyle/>
-            <a:p>
-              <a:pPr>
-                <a:defRPr b="0" i="0" strike="noStrike" sz="1200" u="none">
-                  <a:solidFill>
-                    <a:srgbClr val="2C2A29"/>
-                  </a:solidFill>
-                  <a:latin typeface="+mn-lt"/>
-                </a:defRPr>
-              </a:pPr>
-            </a:p>
-          </c:txPr>
-          <c:showLegendKey val="0"/>
-          <c:showVal val="1"/>
-          <c:showCatName val="0"/>
-          <c:showSerName val="0"/>
-          <c:showPercent val="0"/>
-          <c:showBubbleSize val="0"/>
-          <c:showLeaderLines val="0"/>
-        </c:dLbls>
-        <c:gapWidth val="60"/>
-        <c:overlap val="0"/>
-        <c:axId val="2094734554"/>
-        <c:axId val="2094734552"/>
-        <c:axId val="2094734556"/>
-      </c:barChart>
-      <c:catAx>
-        <c:axId val="2094734554"/>
-        <c:scaling>
-          <c:orientation val="minMax"/>
-        </c:scaling>
-        <c:delete val="0"/>
-        <c:axPos val="l"/>
-        <c:numFmt formatCode="General" sourceLinked="1"/>
-        <c:majorTickMark val="out"/>
-        <c:minorTickMark val="none"/>
-        <c:tickLblPos val="nextTo"/>
-        <c:spPr>
-          <a:ln w="12700" cap="flat">
-            <a:solidFill>
-              <a:srgbClr val="888888"/>
-            </a:solidFill>
-            <a:prstDash val="solid"/>
-            <a:round/>
-          </a:ln>
-        </c:spPr>
-        <c:txPr>
-          <a:bodyPr/>
-          <a:lstStyle/>
-          <a:p>
-            <a:pPr>
-              <a:defRPr sz="1200" b="0" i="0" u="none" strike="noStrike">
-                <a:solidFill>
-                  <a:srgbClr val="595755"/>
-                </a:solidFill>
-                <a:latin typeface="+mn-lt"/>
-              </a:defRPr>
-            </a:pPr>
-            <a:endParaRPr lang="en-US"/>
-          </a:p>
-        </c:txPr>
-        <c:crossAx val="2094734552"/>
-        <c:crosses val="autoZero"/>
-        <c:auto val="1"/>
-        <c:lblAlgn val="ctr"/>
-        <c:noMultiLvlLbl val="1"/>
-      </c:catAx>
-      <c:valAx>
-        <c:axId val="2094734552"/>
-        <c:scaling>
-          <c:orientation val="minMax"/>
-          <c:max val="5"/>
-          <c:min val="0"/>
-        </c:scaling>
-        <c:delete val="1"/>
-        <c:axPos val="b"/>
-        <c:numFmt formatCode="General" sourceLinked="0"/>
-        <c:majorTickMark val="out"/>
-        <c:minorTickMark val="none"/>
-        <c:tickLblPos val="low"/>
-        <c:spPr>
-          <a:ln w="12700" cap="flat">
-            <a:solidFill>
-              <a:srgbClr val="888888"/>
-            </a:solidFill>
-            <a:prstDash val="solid"/>
-            <a:round/>
-          </a:ln>
-        </c:spPr>
-        <c:txPr>
-          <a:bodyPr/>
-          <a:lstStyle/>
-          <a:p>
-            <a:pPr>
-              <a:defRPr sz="1200" b="0" i="0" u="none" strike="noStrike">
-                <a:solidFill>
-                  <a:srgbClr val="000000"/>
-                </a:solidFill>
-                <a:latin typeface="Arial"/>
-              </a:defRPr>
-            </a:pPr>
-            <a:endParaRPr lang="en-US"/>
-          </a:p>
-        </c:txPr>
-        <c:crossAx val="2094734554"/>
-        <c:crosses val="autoZero"/>
-        <c:crossBetween val="between"/>
-      </c:valAx>
-      <c:spPr>
-        <a:noFill/>
-        <a:ln>
-          <a:noFill/>
-        </a:ln>
-        <a:effectLst/>
-      </c:spPr>
-    </c:plotArea>
-    <c:plotVisOnly val="1"/>
-    <c:dispBlanksAs val="span"/>
-  </c:chart>
-  <c:spPr>
-    <a:noFill/>
-    <a:ln>
-      <a:noFill/>
-    </a:ln>
-    <a:effectLst/>
-  </c:spPr>
-  <c:externalData r:id="rId1">
-    <c:autoUpdate val="0"/>
-  </c:externalData>
-</c:chartSpace>
 </file>
 
 <file path=ppt/notesMasters/notesMaster1.xml><?xml version="1.0" encoding="utf-8"?>
@@ -4594,25 +4310,689 @@
           </a:p>
         </p:txBody>
       </p:sp>
-      <p:graphicFrame>
-        <p:nvGraphicFramePr>
-          <p:cNvPr id="14" name="Gráfico causas" descr="Gráfico de barras: factura duplicada 4, sin registro contable 4, campo vacío 3, total no cuadra 3, contabilización pendiente 3, IVA mal calculado 2, valor contabilizado diferente 2"/>
-          <p:cNvGraphicFramePr/>
-          <p:nvPr/>
-        </p:nvGraphicFramePr>
-        <p:xfrm>
-          <a:off x="4846320" y="1325880"/>
-          <a:ext cx="6812280" cy="4023360"/>
-        </p:xfrm>
-        <a:graphic xmlns:a="http://schemas.openxmlformats.org/drawingml/2006/main">
-          <a:graphicData uri="http://schemas.openxmlformats.org/drawingml/2006/chart">
-            <c:chart xmlns:c="http://schemas.openxmlformats.org/drawingml/2006/chart" r:id="rId3"/>
-          </a:graphicData>
-        </a:graphic>
-      </p:graphicFrame>
-      <p:sp>
-        <p:nvSpPr>
-          <p:cNvPr id="15" name="Nota causas"/>
+      <p:sp>
+        <p:nvSpPr>
+          <p:cNvPr id="14" name="Título causas"/>
+          <p:cNvSpPr txBox="1"/>
+          <p:nvPr/>
+        </p:nvSpPr>
+        <p:spPr>
+          <a:xfrm>
+            <a:off x="4846320" y="1371600"/>
+            <a:ext cx="6812280" cy="365760"/>
+          </a:xfrm>
+          <a:prstGeom prst="rect">
+            <a:avLst/>
+          </a:prstGeom>
+          <a:noFill/>
+          <a:ln/>
+        </p:spPr>
+        <p:txBody>
+          <a:bodyPr wrap="square" lIns="0" tIns="0" rIns="0" bIns="0" rtlCol="0" anchor="ctr"/>
+          <a:lstStyle/>
+          <a:p>
+            <a:pPr indent="0" marL="0">
+              <a:buNone/>
+            </a:pPr>
+            <a:r>
+              <a:rPr lang="en-US" sz="1500" b="1" dirty="0">
+                <a:solidFill>
+                  <a:schemeClr val="tx1"/>
+                </a:solidFill>
+              </a:rPr>
+              <a:t>Inconsistencias por causa (número de facturas)</a:t>
+            </a:r>
+            <a:endParaRPr lang="en-US" sz="1500" dirty="0"/>
+          </a:p>
+        </p:txBody>
+      </p:sp>
+      <p:sp>
+        <p:nvSpPr>
+          <p:cNvPr id="15" name="Etiqueta Factura duplicada"/>
+          <p:cNvSpPr txBox="1"/>
+          <p:nvPr/>
+        </p:nvSpPr>
+        <p:spPr>
+          <a:xfrm>
+            <a:off x="4846320" y="1874520"/>
+            <a:ext cx="2697480" cy="365760"/>
+          </a:xfrm>
+          <a:prstGeom prst="rect">
+            <a:avLst/>
+          </a:prstGeom>
+          <a:noFill/>
+          <a:ln/>
+        </p:spPr>
+        <p:txBody>
+          <a:bodyPr wrap="square" lIns="0" tIns="0" rIns="0" bIns="0" rtlCol="0" anchor="ctr"/>
+          <a:lstStyle/>
+          <a:p>
+            <a:pPr algn="r" indent="0" marL="0">
+              <a:buNone/>
+            </a:pPr>
+            <a:r>
+              <a:rPr lang="en-US" sz="1300" dirty="0">
+                <a:solidFill>
+                  <a:schemeClr val="tx1"/>
+                </a:solidFill>
+              </a:rPr>
+              <a:t>Factura duplicada</a:t>
+            </a:r>
+            <a:endParaRPr lang="en-US" sz="1300" dirty="0"/>
+          </a:p>
+        </p:txBody>
+      </p:sp>
+      <p:sp>
+        <p:nvSpPr>
+          <p:cNvPr id="16" name="Barra Factura duplicada"/>
+          <p:cNvSpPr/>
+          <p:nvPr/>
+        </p:nvSpPr>
+        <p:spPr>
+          <a:xfrm>
+            <a:off x="7680960" y="1929384"/>
+            <a:ext cx="3291840" cy="256032"/>
+          </a:xfrm>
+          <a:prstGeom prst="rect">
+            <a:avLst/>
+          </a:prstGeom>
+          <a:solidFill>
+            <a:schemeClr val="accent2"/>
+          </a:solidFill>
+          <a:ln/>
+        </p:spPr>
+      </p:sp>
+      <p:sp>
+        <p:nvSpPr>
+          <p:cNvPr id="17" name="Cantidad Factura duplicada"/>
+          <p:cNvSpPr txBox="1"/>
+          <p:nvPr/>
+        </p:nvSpPr>
+        <p:spPr>
+          <a:xfrm>
+            <a:off x="11064240" y="1874520"/>
+            <a:ext cx="365760" cy="365760"/>
+          </a:xfrm>
+          <a:prstGeom prst="rect">
+            <a:avLst/>
+          </a:prstGeom>
+          <a:noFill/>
+          <a:ln/>
+        </p:spPr>
+        <p:txBody>
+          <a:bodyPr wrap="square" lIns="0" tIns="0" rIns="0" bIns="0" rtlCol="0" anchor="ctr"/>
+          <a:lstStyle/>
+          <a:p>
+            <a:pPr indent="0" marL="0">
+              <a:buNone/>
+            </a:pPr>
+            <a:r>
+              <a:rPr lang="en-US" sz="1400" b="1" dirty="0">
+                <a:solidFill>
+                  <a:schemeClr val="tx1"/>
+                </a:solidFill>
+              </a:rPr>
+              <a:t>4</a:t>
+            </a:r>
+            <a:endParaRPr lang="en-US" sz="1400" dirty="0"/>
+          </a:p>
+        </p:txBody>
+      </p:sp>
+      <p:sp>
+        <p:nvSpPr>
+          <p:cNvPr id="18" name="Etiqueta Sin registro contable"/>
+          <p:cNvSpPr txBox="1"/>
+          <p:nvPr/>
+        </p:nvSpPr>
+        <p:spPr>
+          <a:xfrm>
+            <a:off x="4846320" y="2368296"/>
+            <a:ext cx="2697480" cy="365760"/>
+          </a:xfrm>
+          <a:prstGeom prst="rect">
+            <a:avLst/>
+          </a:prstGeom>
+          <a:noFill/>
+          <a:ln/>
+        </p:spPr>
+        <p:txBody>
+          <a:bodyPr wrap="square" lIns="0" tIns="0" rIns="0" bIns="0" rtlCol="0" anchor="ctr"/>
+          <a:lstStyle/>
+          <a:p>
+            <a:pPr algn="r" indent="0" marL="0">
+              <a:buNone/>
+            </a:pPr>
+            <a:r>
+              <a:rPr lang="en-US" sz="1300" dirty="0">
+                <a:solidFill>
+                  <a:schemeClr val="tx1"/>
+                </a:solidFill>
+              </a:rPr>
+              <a:t>Sin registro contable</a:t>
+            </a:r>
+            <a:endParaRPr lang="en-US" sz="1300" dirty="0"/>
+          </a:p>
+        </p:txBody>
+      </p:sp>
+      <p:sp>
+        <p:nvSpPr>
+          <p:cNvPr id="19" name="Barra Sin registro contable"/>
+          <p:cNvSpPr/>
+          <p:nvPr/>
+        </p:nvSpPr>
+        <p:spPr>
+          <a:xfrm>
+            <a:off x="7680960" y="2423160"/>
+            <a:ext cx="3291840" cy="256032"/>
+          </a:xfrm>
+          <a:prstGeom prst="rect">
+            <a:avLst/>
+          </a:prstGeom>
+          <a:solidFill>
+            <a:schemeClr val="accent2"/>
+          </a:solidFill>
+          <a:ln/>
+        </p:spPr>
+      </p:sp>
+      <p:sp>
+        <p:nvSpPr>
+          <p:cNvPr id="20" name="Cantidad Sin registro contable"/>
+          <p:cNvSpPr txBox="1"/>
+          <p:nvPr/>
+        </p:nvSpPr>
+        <p:spPr>
+          <a:xfrm>
+            <a:off x="11064240" y="2368296"/>
+            <a:ext cx="365760" cy="365760"/>
+          </a:xfrm>
+          <a:prstGeom prst="rect">
+            <a:avLst/>
+          </a:prstGeom>
+          <a:noFill/>
+          <a:ln/>
+        </p:spPr>
+        <p:txBody>
+          <a:bodyPr wrap="square" lIns="0" tIns="0" rIns="0" bIns="0" rtlCol="0" anchor="ctr"/>
+          <a:lstStyle/>
+          <a:p>
+            <a:pPr indent="0" marL="0">
+              <a:buNone/>
+            </a:pPr>
+            <a:r>
+              <a:rPr lang="en-US" sz="1400" b="1" dirty="0">
+                <a:solidFill>
+                  <a:schemeClr val="tx1"/>
+                </a:solidFill>
+              </a:rPr>
+              <a:t>4</a:t>
+            </a:r>
+            <a:endParaRPr lang="en-US" sz="1400" dirty="0"/>
+          </a:p>
+        </p:txBody>
+      </p:sp>
+      <p:sp>
+        <p:nvSpPr>
+          <p:cNvPr id="21" name="Etiqueta Campo obligatorio vacío"/>
+          <p:cNvSpPr txBox="1"/>
+          <p:nvPr/>
+        </p:nvSpPr>
+        <p:spPr>
+          <a:xfrm>
+            <a:off x="4846320" y="2862072"/>
+            <a:ext cx="2697480" cy="365760"/>
+          </a:xfrm>
+          <a:prstGeom prst="rect">
+            <a:avLst/>
+          </a:prstGeom>
+          <a:noFill/>
+          <a:ln/>
+        </p:spPr>
+        <p:txBody>
+          <a:bodyPr wrap="square" lIns="0" tIns="0" rIns="0" bIns="0" rtlCol="0" anchor="ctr"/>
+          <a:lstStyle/>
+          <a:p>
+            <a:pPr algn="r" indent="0" marL="0">
+              <a:buNone/>
+            </a:pPr>
+            <a:r>
+              <a:rPr lang="en-US" sz="1300" dirty="0">
+                <a:solidFill>
+                  <a:schemeClr val="tx1"/>
+                </a:solidFill>
+              </a:rPr>
+              <a:t>Campo obligatorio vacío</a:t>
+            </a:r>
+            <a:endParaRPr lang="en-US" sz="1300" dirty="0"/>
+          </a:p>
+        </p:txBody>
+      </p:sp>
+      <p:sp>
+        <p:nvSpPr>
+          <p:cNvPr id="22" name="Barra Campo obligatorio vacío"/>
+          <p:cNvSpPr/>
+          <p:nvPr/>
+        </p:nvSpPr>
+        <p:spPr>
+          <a:xfrm>
+            <a:off x="7680960" y="2916936"/>
+            <a:ext cx="2468880" cy="256032"/>
+          </a:xfrm>
+          <a:prstGeom prst="rect">
+            <a:avLst/>
+          </a:prstGeom>
+          <a:solidFill>
+            <a:schemeClr val="accent2"/>
+          </a:solidFill>
+          <a:ln/>
+        </p:spPr>
+      </p:sp>
+      <p:sp>
+        <p:nvSpPr>
+          <p:cNvPr id="23" name="Cantidad Campo obligatorio vacío"/>
+          <p:cNvSpPr txBox="1"/>
+          <p:nvPr/>
+        </p:nvSpPr>
+        <p:spPr>
+          <a:xfrm>
+            <a:off x="10241280" y="2862072"/>
+            <a:ext cx="365760" cy="365760"/>
+          </a:xfrm>
+          <a:prstGeom prst="rect">
+            <a:avLst/>
+          </a:prstGeom>
+          <a:noFill/>
+          <a:ln/>
+        </p:spPr>
+        <p:txBody>
+          <a:bodyPr wrap="square" lIns="0" tIns="0" rIns="0" bIns="0" rtlCol="0" anchor="ctr"/>
+          <a:lstStyle/>
+          <a:p>
+            <a:pPr indent="0" marL="0">
+              <a:buNone/>
+            </a:pPr>
+            <a:r>
+              <a:rPr lang="en-US" sz="1400" b="1" dirty="0">
+                <a:solidFill>
+                  <a:schemeClr val="tx1"/>
+                </a:solidFill>
+              </a:rPr>
+              <a:t>3</a:t>
+            </a:r>
+            <a:endParaRPr lang="en-US" sz="1400" dirty="0"/>
+          </a:p>
+        </p:txBody>
+      </p:sp>
+      <p:sp>
+        <p:nvSpPr>
+          <p:cNvPr id="24" name="Etiqueta Total no cuadra"/>
+          <p:cNvSpPr txBox="1"/>
+          <p:nvPr/>
+        </p:nvSpPr>
+        <p:spPr>
+          <a:xfrm>
+            <a:off x="4846320" y="3355848"/>
+            <a:ext cx="2697480" cy="365760"/>
+          </a:xfrm>
+          <a:prstGeom prst="rect">
+            <a:avLst/>
+          </a:prstGeom>
+          <a:noFill/>
+          <a:ln/>
+        </p:spPr>
+        <p:txBody>
+          <a:bodyPr wrap="square" lIns="0" tIns="0" rIns="0" bIns="0" rtlCol="0" anchor="ctr"/>
+          <a:lstStyle/>
+          <a:p>
+            <a:pPr algn="r" indent="0" marL="0">
+              <a:buNone/>
+            </a:pPr>
+            <a:r>
+              <a:rPr lang="en-US" sz="1300" dirty="0">
+                <a:solidFill>
+                  <a:schemeClr val="tx1"/>
+                </a:solidFill>
+              </a:rPr>
+              <a:t>Total no cuadra</a:t>
+            </a:r>
+            <a:endParaRPr lang="en-US" sz="1300" dirty="0"/>
+          </a:p>
+        </p:txBody>
+      </p:sp>
+      <p:sp>
+        <p:nvSpPr>
+          <p:cNvPr id="25" name="Barra Total no cuadra"/>
+          <p:cNvSpPr/>
+          <p:nvPr/>
+        </p:nvSpPr>
+        <p:spPr>
+          <a:xfrm>
+            <a:off x="7680960" y="3410712"/>
+            <a:ext cx="2468880" cy="256032"/>
+          </a:xfrm>
+          <a:prstGeom prst="rect">
+            <a:avLst/>
+          </a:prstGeom>
+          <a:solidFill>
+            <a:schemeClr val="accent2"/>
+          </a:solidFill>
+          <a:ln/>
+        </p:spPr>
+      </p:sp>
+      <p:sp>
+        <p:nvSpPr>
+          <p:cNvPr id="26" name="Cantidad Total no cuadra"/>
+          <p:cNvSpPr txBox="1"/>
+          <p:nvPr/>
+        </p:nvSpPr>
+        <p:spPr>
+          <a:xfrm>
+            <a:off x="10241280" y="3355848"/>
+            <a:ext cx="365760" cy="365760"/>
+          </a:xfrm>
+          <a:prstGeom prst="rect">
+            <a:avLst/>
+          </a:prstGeom>
+          <a:noFill/>
+          <a:ln/>
+        </p:spPr>
+        <p:txBody>
+          <a:bodyPr wrap="square" lIns="0" tIns="0" rIns="0" bIns="0" rtlCol="0" anchor="ctr"/>
+          <a:lstStyle/>
+          <a:p>
+            <a:pPr indent="0" marL="0">
+              <a:buNone/>
+            </a:pPr>
+            <a:r>
+              <a:rPr lang="en-US" sz="1400" b="1" dirty="0">
+                <a:solidFill>
+                  <a:schemeClr val="tx1"/>
+                </a:solidFill>
+              </a:rPr>
+              <a:t>3</a:t>
+            </a:r>
+            <a:endParaRPr lang="en-US" sz="1400" dirty="0"/>
+          </a:p>
+        </p:txBody>
+      </p:sp>
+      <p:sp>
+        <p:nvSpPr>
+          <p:cNvPr id="27" name="Etiqueta Contabilización pendiente"/>
+          <p:cNvSpPr txBox="1"/>
+          <p:nvPr/>
+        </p:nvSpPr>
+        <p:spPr>
+          <a:xfrm>
+            <a:off x="4846320" y="3849624"/>
+            <a:ext cx="2697480" cy="365760"/>
+          </a:xfrm>
+          <a:prstGeom prst="rect">
+            <a:avLst/>
+          </a:prstGeom>
+          <a:noFill/>
+          <a:ln/>
+        </p:spPr>
+        <p:txBody>
+          <a:bodyPr wrap="square" lIns="0" tIns="0" rIns="0" bIns="0" rtlCol="0" anchor="ctr"/>
+          <a:lstStyle/>
+          <a:p>
+            <a:pPr algn="r" indent="0" marL="0">
+              <a:buNone/>
+            </a:pPr>
+            <a:r>
+              <a:rPr lang="en-US" sz="1300" dirty="0">
+                <a:solidFill>
+                  <a:schemeClr val="tx1"/>
+                </a:solidFill>
+              </a:rPr>
+              <a:t>Contabilización pendiente</a:t>
+            </a:r>
+            <a:endParaRPr lang="en-US" sz="1300" dirty="0"/>
+          </a:p>
+        </p:txBody>
+      </p:sp>
+      <p:sp>
+        <p:nvSpPr>
+          <p:cNvPr id="28" name="Barra Contabilización pendiente"/>
+          <p:cNvSpPr/>
+          <p:nvPr/>
+        </p:nvSpPr>
+        <p:spPr>
+          <a:xfrm>
+            <a:off x="7680960" y="3904488"/>
+            <a:ext cx="2468880" cy="256032"/>
+          </a:xfrm>
+          <a:prstGeom prst="rect">
+            <a:avLst/>
+          </a:prstGeom>
+          <a:solidFill>
+            <a:schemeClr val="accent2"/>
+          </a:solidFill>
+          <a:ln/>
+        </p:spPr>
+      </p:sp>
+      <p:sp>
+        <p:nvSpPr>
+          <p:cNvPr id="29" name="Cantidad Contabilización pendiente"/>
+          <p:cNvSpPr txBox="1"/>
+          <p:nvPr/>
+        </p:nvSpPr>
+        <p:spPr>
+          <a:xfrm>
+            <a:off x="10241280" y="3849624"/>
+            <a:ext cx="365760" cy="365760"/>
+          </a:xfrm>
+          <a:prstGeom prst="rect">
+            <a:avLst/>
+          </a:prstGeom>
+          <a:noFill/>
+          <a:ln/>
+        </p:spPr>
+        <p:txBody>
+          <a:bodyPr wrap="square" lIns="0" tIns="0" rIns="0" bIns="0" rtlCol="0" anchor="ctr"/>
+          <a:lstStyle/>
+          <a:p>
+            <a:pPr indent="0" marL="0">
+              <a:buNone/>
+            </a:pPr>
+            <a:r>
+              <a:rPr lang="en-US" sz="1400" b="1" dirty="0">
+                <a:solidFill>
+                  <a:schemeClr val="tx1"/>
+                </a:solidFill>
+              </a:rPr>
+              <a:t>3</a:t>
+            </a:r>
+            <a:endParaRPr lang="en-US" sz="1400" dirty="0"/>
+          </a:p>
+        </p:txBody>
+      </p:sp>
+      <p:sp>
+        <p:nvSpPr>
+          <p:cNvPr id="30" name="Etiqueta IVA mal calculado"/>
+          <p:cNvSpPr txBox="1"/>
+          <p:nvPr/>
+        </p:nvSpPr>
+        <p:spPr>
+          <a:xfrm>
+            <a:off x="4846320" y="4343400"/>
+            <a:ext cx="2697480" cy="365760"/>
+          </a:xfrm>
+          <a:prstGeom prst="rect">
+            <a:avLst/>
+          </a:prstGeom>
+          <a:noFill/>
+          <a:ln/>
+        </p:spPr>
+        <p:txBody>
+          <a:bodyPr wrap="square" lIns="0" tIns="0" rIns="0" bIns="0" rtlCol="0" anchor="ctr"/>
+          <a:lstStyle/>
+          <a:p>
+            <a:pPr algn="r" indent="0" marL="0">
+              <a:buNone/>
+            </a:pPr>
+            <a:r>
+              <a:rPr lang="en-US" sz="1300" dirty="0">
+                <a:solidFill>
+                  <a:schemeClr val="tx1"/>
+                </a:solidFill>
+              </a:rPr>
+              <a:t>IVA mal calculado</a:t>
+            </a:r>
+            <a:endParaRPr lang="en-US" sz="1300" dirty="0"/>
+          </a:p>
+        </p:txBody>
+      </p:sp>
+      <p:sp>
+        <p:nvSpPr>
+          <p:cNvPr id="31" name="Barra IVA mal calculado"/>
+          <p:cNvSpPr/>
+          <p:nvPr/>
+        </p:nvSpPr>
+        <p:spPr>
+          <a:xfrm>
+            <a:off x="7680960" y="4398264"/>
+            <a:ext cx="1645920" cy="256032"/>
+          </a:xfrm>
+          <a:prstGeom prst="rect">
+            <a:avLst/>
+          </a:prstGeom>
+          <a:solidFill>
+            <a:schemeClr val="accent2"/>
+          </a:solidFill>
+          <a:ln/>
+        </p:spPr>
+      </p:sp>
+      <p:sp>
+        <p:nvSpPr>
+          <p:cNvPr id="32" name="Cantidad IVA mal calculado"/>
+          <p:cNvSpPr txBox="1"/>
+          <p:nvPr/>
+        </p:nvSpPr>
+        <p:spPr>
+          <a:xfrm>
+            <a:off x="9418320" y="4343400"/>
+            <a:ext cx="365760" cy="365760"/>
+          </a:xfrm>
+          <a:prstGeom prst="rect">
+            <a:avLst/>
+          </a:prstGeom>
+          <a:noFill/>
+          <a:ln/>
+        </p:spPr>
+        <p:txBody>
+          <a:bodyPr wrap="square" lIns="0" tIns="0" rIns="0" bIns="0" rtlCol="0" anchor="ctr"/>
+          <a:lstStyle/>
+          <a:p>
+            <a:pPr indent="0" marL="0">
+              <a:buNone/>
+            </a:pPr>
+            <a:r>
+              <a:rPr lang="en-US" sz="1400" b="1" dirty="0">
+                <a:solidFill>
+                  <a:schemeClr val="tx1"/>
+                </a:solidFill>
+              </a:rPr>
+              <a:t>2</a:t>
+            </a:r>
+            <a:endParaRPr lang="en-US" sz="1400" dirty="0"/>
+          </a:p>
+        </p:txBody>
+      </p:sp>
+      <p:sp>
+        <p:nvSpPr>
+          <p:cNvPr id="33" name="Etiqueta Valor contabilizado diferente"/>
+          <p:cNvSpPr txBox="1"/>
+          <p:nvPr/>
+        </p:nvSpPr>
+        <p:spPr>
+          <a:xfrm>
+            <a:off x="4846320" y="4837176"/>
+            <a:ext cx="2697480" cy="365760"/>
+          </a:xfrm>
+          <a:prstGeom prst="rect">
+            <a:avLst/>
+          </a:prstGeom>
+          <a:noFill/>
+          <a:ln/>
+        </p:spPr>
+        <p:txBody>
+          <a:bodyPr wrap="square" lIns="0" tIns="0" rIns="0" bIns="0" rtlCol="0" anchor="ctr"/>
+          <a:lstStyle/>
+          <a:p>
+            <a:pPr algn="r" indent="0" marL="0">
+              <a:buNone/>
+            </a:pPr>
+            <a:r>
+              <a:rPr lang="en-US" sz="1300" dirty="0">
+                <a:solidFill>
+                  <a:schemeClr val="tx1"/>
+                </a:solidFill>
+              </a:rPr>
+              <a:t>Valor contabilizado diferente</a:t>
+            </a:r>
+            <a:endParaRPr lang="en-US" sz="1300" dirty="0"/>
+          </a:p>
+        </p:txBody>
+      </p:sp>
+      <p:sp>
+        <p:nvSpPr>
+          <p:cNvPr id="34" name="Barra Valor contabilizado diferente"/>
+          <p:cNvSpPr/>
+          <p:nvPr/>
+        </p:nvSpPr>
+        <p:spPr>
+          <a:xfrm>
+            <a:off x="7680960" y="4892040"/>
+            <a:ext cx="1645920" cy="256032"/>
+          </a:xfrm>
+          <a:prstGeom prst="rect">
+            <a:avLst/>
+          </a:prstGeom>
+          <a:solidFill>
+            <a:schemeClr val="accent2"/>
+          </a:solidFill>
+          <a:ln/>
+        </p:spPr>
+      </p:sp>
+      <p:sp>
+        <p:nvSpPr>
+          <p:cNvPr id="35" name="Cantidad Valor contabilizado diferente"/>
+          <p:cNvSpPr txBox="1"/>
+          <p:nvPr/>
+        </p:nvSpPr>
+        <p:spPr>
+          <a:xfrm>
+            <a:off x="9418320" y="4837176"/>
+            <a:ext cx="365760" cy="365760"/>
+          </a:xfrm>
+          <a:prstGeom prst="rect">
+            <a:avLst/>
+          </a:prstGeom>
+          <a:noFill/>
+          <a:ln/>
+        </p:spPr>
+        <p:txBody>
+          <a:bodyPr wrap="square" lIns="0" tIns="0" rIns="0" bIns="0" rtlCol="0" anchor="ctr"/>
+          <a:lstStyle/>
+          <a:p>
+            <a:pPr indent="0" marL="0">
+              <a:buNone/>
+            </a:pPr>
+            <a:r>
+              <a:rPr lang="en-US" sz="1400" b="1" dirty="0">
+                <a:solidFill>
+                  <a:schemeClr val="tx1"/>
+                </a:solidFill>
+              </a:rPr>
+              <a:t>2</a:t>
+            </a:r>
+            <a:endParaRPr lang="en-US" sz="1400" dirty="0"/>
+          </a:p>
+        </p:txBody>
+      </p:sp>
+      <p:sp>
+        <p:nvSpPr>
+          <p:cNvPr id="36" name="Nota causas"/>
           <p:cNvSpPr txBox="1"/>
           <p:nvPr/>
         </p:nvSpPr>
@@ -4648,7 +5028,7 @@
       </p:sp>
       <p:sp>
         <p:nvSpPr>
-          <p:cNvPr id="16" name="Montos"/>
+          <p:cNvPr id="37" name="Montos"/>
           <p:cNvSpPr txBox="1"/>
           <p:nvPr/>
         </p:nvSpPr>

</xml_diff>

<commit_message>
fix(presentacion): textos fieles al sistema y al enunciado
Co-Authored-By: Claude Opus 5.5 <noreply@anthropic.com>
</commit_message>
<xml_diff>
--- a/docs/presentacion/presentacion-conciliador.pptx
+++ b/docs/presentacion/presentacion-conciliador.pptx
@@ -111,27 +111,27 @@
   <p:extLst>
     <p:ext uri="{521415D9-36F7-43E2-AB2F-B90AF26B5E84}">
       <p14:sectionLst xmlns:p14="http://schemas.microsoft.com/office/powerpoint/2010/main">
-        <p14:section name="Problema" id="{950aa038-b966-8d64-3eda-5caf6d646016}">
+        <p14:section name="Problema" id="{33efeed4-4963-28b5-8ff3-219a65bb7d7b}">
           <p14:sldIdLst>
             <p14:sldId id="256"/>
           </p14:sldIdLst>
         </p14:section>
-        <p14:section name="Solución" id="{03fbbf10-585d-29b3-6c8b-57e6b261db6a}">
+        <p14:section name="Solución" id="{fb4f629b-4ea8-bd8a-5345-a2e84536f732}">
           <p14:sldIdLst>
             <p14:sldId id="257"/>
           </p14:sldIdLst>
         </p14:section>
-        <p14:section name="Flujo" id="{5993489e-674f-c5a0-bfd9-91439bd41b09}">
+        <p14:section name="Flujo" id="{e2d0fc64-d806-df5d-f11a-3012782ebf7a}">
           <p14:sldIdLst>
             <p14:sldId id="258"/>
           </p14:sldIdLst>
         </p14:section>
-        <p14:section name="Resultados" id="{444e6589-fa6c-573b-a8c3-0bc9ebaf6682}">
+        <p14:section name="Resultados" id="{42d2c396-5960-2a70-3177-d84a4798523d}">
           <p14:sldIdLst>
             <p14:sldId id="259"/>
           </p14:sldIdLst>
         </p14:section>
-        <p14:section name="Beneficios" id="{c3986134-8dac-941a-328f-5951f7a85f11}">
+        <p14:section name="Beneficios" id="{57140014-5be7-e084-d01c-7fccefe4430e}">
           <p14:sldIdLst>
             <p14:sldId id="260"/>
           </p14:sldIdLst>
@@ -540,7 +540,7 @@
           <a:p>
             <a:r>
               <a:rPr lang="en-US" dirty="0"/>
-              <a:t>Hoy la conciliación entre facturas de proveedores y registros contables es manual. El enunciado lo resume en tres problemas: consume tiempo, dificulta la trazabilidad y genera reprocesos. El prototipo busca automatizar el cruce y dejar explicada cada diferencia.</a:t>
+              <a:t>Hoy la conciliación entre facturas de proveedores y registros contables es manual. El enunciado lo resume en tres problemas: consume tiempo, dificulta la trazabilidad y puede generar reprocesos. El prototipo busca automatizar el cruce y dejar explicada cada diferencia.</a:t>
             </a:r>
             <a:endParaRPr lang="en-US" dirty="0"/>
           </a:p>
@@ -1947,7 +1947,7 @@
       </p:sp>
       <p:sp>
         <p:nvSpPr>
-          <p:cNvPr id="13" name="Círculo Genera reprocesos"/>
+          <p:cNvPr id="13" name="Círculo Puede generar reprocesos"/>
           <p:cNvSpPr/>
           <p:nvPr/>
         </p:nvSpPr>
@@ -1972,7 +1972,7 @@
       </p:sp>
       <p:pic>
         <p:nvPicPr>
-          <p:cNvPr id="14" name="Ícono Genera reprocesos" descr="Genera reprocesos">    </p:cNvPr>
+          <p:cNvPr id="14" name="Ícono Puede generar reprocesos" descr="Puede generar reprocesos">    </p:cNvPr>
           <p:cNvPicPr>
             <a:picLocks noChangeAspect="1"/>
           </p:cNvPicPr>
@@ -1996,7 +1996,7 @@
       </p:pic>
       <p:sp>
         <p:nvSpPr>
-          <p:cNvPr id="15" name="Punto Genera reprocesos"/>
+          <p:cNvPr id="15" name="Punto Puede generar reprocesos"/>
           <p:cNvSpPr txBox="1"/>
           <p:nvPr/>
         </p:nvSpPr>
@@ -2024,7 +2024,7 @@
                   <a:schemeClr val="tx1"/>
                 </a:solidFill>
               </a:rPr>
-              <a:t>Genera reprocesos</a:t>
+              <a:t>Puede generar reprocesos</a:t>
             </a:r>
             <a:endParaRPr lang="en-US" sz="1800" dirty="0"/>
           </a:p>
@@ -2524,7 +2524,7 @@
                   <a:schemeClr val="tx2"/>
                 </a:solidFill>
               </a:rPr>
-              <a:t>Muestra la causa con el valor reportado, el esperado y la diferencia.</a:t>
+              <a:t>Muestra la causa de cada una y, en los cálculos, el valor reportado, el esperado y la diferencia.</a:t>
             </a:r>
             <a:endParaRPr lang="en-US" sz="1600" dirty="0"/>
           </a:p>
@@ -5460,7 +5460,7 @@
                   <a:schemeClr val="tx1"/>
                 </a:solidFill>
               </a:rPr>
-              <a:t>El cruce se hace automáticamente al cargar los archivos.</a:t>
+              <a:t>El cruce se hace automáticamente con un clic.</a:t>
             </a:r>
             <a:endParaRPr lang="en-US" sz="1400" dirty="0"/>
           </a:p>
@@ -5671,7 +5671,7 @@
                   <a:schemeClr val="tx1"/>
                 </a:solidFill>
               </a:rPr>
-              <a:t>Cada causa muestra el valor reportado, el esperado y la diferencia.</a:t>
+              <a:t>Cada inconsistencia queda explicada; en los cálculos, con lo reportado, lo esperado y la diferencia.</a:t>
             </a:r>
             <a:endParaRPr lang="en-US" sz="1400" dirty="0"/>
           </a:p>
@@ -5819,7 +5819,7 @@
                   <a:schemeClr val="tx2"/>
                 </a:solidFill>
               </a:rPr>
-              <a:t>El resultado depende de quién revisa.</a:t>
+              <a:t>Cada revisión manual puede aplicar criterios distintos.</a:t>
             </a:r>
             <a:endParaRPr lang="en-US" sz="1400" dirty="0"/>
           </a:p>
@@ -6030,7 +6030,7 @@
                   <a:schemeClr val="tx2"/>
                 </a:solidFill>
               </a:rPr>
-              <a:t>Las diferencias se detectan tarde.</a:t>
+              <a:t>Los errores pueden generar reprocesos.</a:t>
             </a:r>
             <a:endParaRPr lang="en-US" sz="1400" dirty="0"/>
           </a:p>

</xml_diff>